<commit_message>
feat: update presentation final version
</commit_message>
<xml_diff>
--- a/reports/credit_score_classification_presentation.pptx
+++ b/reports/credit_score_classification_presentation.pptx
@@ -5,7 +5,7 @@
     <p:sldMasterId id="2147483648" r:id="rId1"/>
   </p:sldMasterIdLst>
   <p:notesMasterIdLst>
-    <p:notesMasterId r:id="rId18"/>
+    <p:notesMasterId r:id="rId21"/>
   </p:notesMasterIdLst>
   <p:sldIdLst>
     <p:sldId id="256" r:id="rId2"/>
@@ -24,6 +24,9 @@
     <p:sldId id="269" r:id="rId15"/>
     <p:sldId id="270" r:id="rId16"/>
     <p:sldId id="271" r:id="rId17"/>
+    <p:sldId id="274" r:id="rId18"/>
+    <p:sldId id="275" r:id="rId19"/>
+    <p:sldId id="276" r:id="rId20"/>
   </p:sldIdLst>
   <p:sldSz cx="12192000" cy="6858000"/>
   <p:notesSz cx="6858000" cy="12192000"/>
@@ -930,6 +933,174 @@
             <a:fld id="{F7021451-1387-4CA6-816F-3879F97B5CBC}" type="slidenum">
               <a:rPr lang="en-US"/>
               <a:t>16</a:t>
+            </a:fld>
+            <a:endParaRPr lang="en-US"/>
+          </a:p>
+        </p:txBody>
+      </p:sp>
+    </p:spTree>
+    <p:extLst>
+      <p:ext uri="{BB962C8B-B14F-4D97-AF65-F5344CB8AC3E}">
+        <p14:creationId xmlns:p14="http://schemas.microsoft.com/office/powerpoint/2010/main" val="1024086991"/>
+      </p:ext>
+    </p:extLst>
+  </p:cSld>
+  <p:clrMapOvr>
+    <a:masterClrMapping/>
+  </p:clrMapOvr>
+</p:notes>
+</file>
+
+<file path=ppt/notesSlides/notesSlide17.xml><?xml version="1.0" encoding="utf-8"?>
+<p:notes xmlns:a="http://schemas.openxmlformats.org/drawingml/2006/main" xmlns:r="http://schemas.openxmlformats.org/officeDocument/2006/relationships" xmlns:p="http://schemas.openxmlformats.org/presentationml/2006/main">
+  <p:cSld>
+    <p:spTree>
+      <p:nvGrpSpPr>
+        <p:cNvPr id="1" name=""/>
+        <p:cNvGrpSpPr/>
+        <p:nvPr/>
+      </p:nvGrpSpPr>
+      <p:grpSpPr>
+        <a:xfrm>
+          <a:off x="0" y="0"/>
+          <a:ext cx="0" cy="0"/>
+          <a:chOff x="0" y="0"/>
+          <a:chExt cx="0" cy="0"/>
+        </a:xfrm>
+      </p:grpSpPr>
+      <p:sp>
+        <p:nvSpPr>
+          <p:cNvPr id="2" name="Slide Image Placeholder 1"/>
+          <p:cNvSpPr>
+            <a:spLocks noGrp="1" noRot="1" noChangeAspect="1"/>
+          </p:cNvSpPr>
+          <p:nvPr>
+            <p:ph type="sldImg"/>
+          </p:nvPr>
+        </p:nvSpPr>
+        <p:spPr/>
+      </p:sp>
+      <p:sp>
+        <p:nvSpPr>
+          <p:cNvPr id="3" name="Notes Placeholder 2"/>
+          <p:cNvSpPr>
+            <a:spLocks noGrp="1"/>
+          </p:cNvSpPr>
+          <p:nvPr>
+            <p:ph type="body" idx="1"/>
+          </p:nvPr>
+        </p:nvSpPr>
+        <p:spPr/>
+        <p:txBody>
+          <a:bodyPr/>
+          <a:lstStyle/>
+          <a:p>
+            <a:endParaRPr lang="en-US" dirty="0"/>
+          </a:p>
+        </p:txBody>
+      </p:sp>
+      <p:sp>
+        <p:nvSpPr>
+          <p:cNvPr id="4" name="Slide Number Placeholder 3"/>
+          <p:cNvSpPr>
+            <a:spLocks noGrp="1"/>
+          </p:cNvSpPr>
+          <p:nvPr>
+            <p:ph type="sldNum" sz="quarter" idx="10"/>
+          </p:nvPr>
+        </p:nvSpPr>
+        <p:spPr/>
+        <p:txBody>
+          <a:bodyPr/>
+          <a:lstStyle/>
+          <a:p>
+            <a:fld id="{F7021451-1387-4CA6-816F-3879F97B5CBC}" type="slidenum">
+              <a:rPr lang="en-US"/>
+              <a:t>18</a:t>
+            </a:fld>
+            <a:endParaRPr lang="en-US"/>
+          </a:p>
+        </p:txBody>
+      </p:sp>
+    </p:spTree>
+    <p:extLst>
+      <p:ext uri="{BB962C8B-B14F-4D97-AF65-F5344CB8AC3E}">
+        <p14:creationId xmlns:p14="http://schemas.microsoft.com/office/powerpoint/2010/main" val="1024086991"/>
+      </p:ext>
+    </p:extLst>
+  </p:cSld>
+  <p:clrMapOvr>
+    <a:masterClrMapping/>
+  </p:clrMapOvr>
+</p:notes>
+</file>
+
+<file path=ppt/notesSlides/notesSlide18.xml><?xml version="1.0" encoding="utf-8"?>
+<p:notes xmlns:a="http://schemas.openxmlformats.org/drawingml/2006/main" xmlns:r="http://schemas.openxmlformats.org/officeDocument/2006/relationships" xmlns:p="http://schemas.openxmlformats.org/presentationml/2006/main">
+  <p:cSld>
+    <p:spTree>
+      <p:nvGrpSpPr>
+        <p:cNvPr id="1" name=""/>
+        <p:cNvGrpSpPr/>
+        <p:nvPr/>
+      </p:nvGrpSpPr>
+      <p:grpSpPr>
+        <a:xfrm>
+          <a:off x="0" y="0"/>
+          <a:ext cx="0" cy="0"/>
+          <a:chOff x="0" y="0"/>
+          <a:chExt cx="0" cy="0"/>
+        </a:xfrm>
+      </p:grpSpPr>
+      <p:sp>
+        <p:nvSpPr>
+          <p:cNvPr id="2" name="Slide Image Placeholder 1"/>
+          <p:cNvSpPr>
+            <a:spLocks noGrp="1" noRot="1" noChangeAspect="1"/>
+          </p:cNvSpPr>
+          <p:nvPr>
+            <p:ph type="sldImg"/>
+          </p:nvPr>
+        </p:nvSpPr>
+        <p:spPr/>
+      </p:sp>
+      <p:sp>
+        <p:nvSpPr>
+          <p:cNvPr id="3" name="Notes Placeholder 2"/>
+          <p:cNvSpPr>
+            <a:spLocks noGrp="1"/>
+          </p:cNvSpPr>
+          <p:nvPr>
+            <p:ph type="body" idx="1"/>
+          </p:nvPr>
+        </p:nvSpPr>
+        <p:spPr/>
+        <p:txBody>
+          <a:bodyPr/>
+          <a:lstStyle/>
+          <a:p>
+            <a:endParaRPr lang="en-US" dirty="0"/>
+          </a:p>
+        </p:txBody>
+      </p:sp>
+      <p:sp>
+        <p:nvSpPr>
+          <p:cNvPr id="4" name="Slide Number Placeholder 3"/>
+          <p:cNvSpPr>
+            <a:spLocks noGrp="1"/>
+          </p:cNvSpPr>
+          <p:nvPr>
+            <p:ph type="sldNum" sz="quarter" idx="10"/>
+          </p:nvPr>
+        </p:nvSpPr>
+        <p:spPr/>
+        <p:txBody>
+          <a:bodyPr/>
+          <a:lstStyle/>
+          <a:p>
+            <a:fld id="{F7021451-1387-4CA6-816F-3879F97B5CBC}" type="slidenum">
+              <a:rPr lang="en-US"/>
+              <a:t>19</a:t>
             </a:fld>
             <a:endParaRPr lang="en-US"/>
           </a:p>
@@ -11011,6 +11182,3498 @@
               </a:rPr>
               <a:t>max_depth [15, 25, None], min_samples_leaf [1, 5]</a:t>
             </a:r>
+          </a:p>
+        </p:txBody>
+      </p:sp>
+    </p:spTree>
+  </p:cSld>
+  <p:clrMapOvr>
+    <a:masterClrMapping/>
+  </p:clrMapOvr>
+</p:sld>
+</file>
+
+<file path=ppt/slides/slide17.xml><?xml version="1.0" encoding="utf-8"?>
+<p:sld xmlns:a="http://schemas.openxmlformats.org/drawingml/2006/main" xmlns:r="http://schemas.openxmlformats.org/officeDocument/2006/relationships" xmlns:p="http://schemas.openxmlformats.org/presentationml/2006/main">
+  <p:cSld>
+    <p:spTree>
+      <p:nvGrpSpPr>
+        <p:cNvPr id="1" name=""/>
+        <p:cNvGrpSpPr/>
+        <p:nvPr/>
+      </p:nvGrpSpPr>
+      <p:grpSpPr>
+        <a:xfrm>
+          <a:off x="0" y="0"/>
+          <a:ext cx="0" cy="0"/>
+          <a:chOff x="0" y="0"/>
+          <a:chExt cx="0" cy="0"/>
+        </a:xfrm>
+      </p:grpSpPr>
+      <p:sp>
+        <p:nvSpPr>
+          <p:cNvPr id="2" name="TopBar"/>
+          <p:cNvSpPr/>
+          <p:nvPr/>
+        </p:nvSpPr>
+        <p:spPr>
+          <a:xfrm>
+            <a:off x="0" y="-26633"/>
+            <a:ext cx="12191695" cy="128016"/>
+          </a:xfrm>
+          <a:prstGeom prst="rect">
+            <a:avLst/>
+          </a:prstGeom>
+          <a:solidFill>
+            <a:srgbClr val="0F766E"/>
+          </a:solidFill>
+          <a:ln w="12700">
+            <a:solidFill>
+              <a:srgbClr val="0F766E"/>
+            </a:solidFill>
+            <a:prstDash val="solid"/>
+          </a:ln>
+        </p:spPr>
+        <p:txBody>
+          <a:bodyPr/>
+          <a:lstStyle/>
+          <a:p>
+            <a:endParaRPr lang="ko-KR" altLang="en-US"/>
+          </a:p>
+        </p:txBody>
+      </p:sp>
+      <p:sp>
+        <p:nvSpPr>
+          <p:cNvPr id="4" name="FooterR"/>
+          <p:cNvSpPr/>
+          <p:nvPr/>
+        </p:nvSpPr>
+        <p:spPr>
+          <a:xfrm>
+            <a:off x="8778240" y="6510528"/>
+            <a:ext cx="2926080" cy="164592"/>
+          </a:xfrm>
+          <a:prstGeom prst="rect">
+            <a:avLst/>
+          </a:prstGeom>
+          <a:noFill/>
+          <a:ln/>
+        </p:spPr>
+        <p:txBody>
+          <a:bodyPr wrap="square" lIns="0" tIns="0" rIns="0" bIns="0" rtlCol="0" anchor="ctr"/>
+          <a:lstStyle/>
+          <a:p>
+            <a:pPr marL="0" indent="0" algn="r">
+              <a:buNone/>
+            </a:pPr>
+            <a:r>
+              <a:rPr lang="en-US" sz="750" dirty="0">
+                <a:solidFill>
+                  <a:srgbClr val="7B8495"/>
+                </a:solidFill>
+                <a:latin typeface="Aptos" pitchFamily="34" charset="0"/>
+              </a:rPr>
+              <a:t>Team 6 Data Science Term Project</a:t>
+            </a:r>
+          </a:p>
+        </p:txBody>
+      </p:sp>
+      <p:sp>
+        <p:nvSpPr>
+          <p:cNvPr id="5" name="SectionLabel"/>
+          <p:cNvSpPr/>
+          <p:nvPr/>
+        </p:nvSpPr>
+        <p:spPr>
+          <a:xfrm>
+            <a:off x="438912" y="347472"/>
+            <a:ext cx="5120640" cy="228600"/>
+          </a:xfrm>
+          <a:prstGeom prst="rect">
+            <a:avLst/>
+          </a:prstGeom>
+          <a:noFill/>
+          <a:ln/>
+        </p:spPr>
+        <p:txBody>
+          <a:bodyPr wrap="square" lIns="0" tIns="0" rIns="0" bIns="0" rtlCol="0" anchor="ctr"/>
+          <a:lstStyle/>
+          <a:p>
+            <a:pPr marL="0" indent="0">
+              <a:buNone/>
+            </a:pPr>
+            <a:r>
+              <a:rPr lang="en-US" sz="850" b="1" dirty="0">
+                <a:solidFill>
+                  <a:srgbClr val="0F766E"/>
+                </a:solidFill>
+                <a:latin typeface="Aptos" pitchFamily="34" charset="0"/>
+              </a:rPr>
+              <a:t>AUXILIARY TASKS</a:t>
+            </a:r>
+          </a:p>
+        </p:txBody>
+      </p:sp>
+      <p:sp>
+        <p:nvSpPr>
+          <p:cNvPr id="6" name="Title"/>
+          <p:cNvSpPr/>
+          <p:nvPr/>
+        </p:nvSpPr>
+        <p:spPr>
+          <a:xfrm>
+            <a:off x="438912" y="621792"/>
+            <a:ext cx="9784080" cy="438912"/>
+          </a:xfrm>
+          <a:prstGeom prst="rect">
+            <a:avLst/>
+          </a:prstGeom>
+          <a:noFill/>
+          <a:ln/>
+        </p:spPr>
+        <p:txBody>
+          <a:bodyPr wrap="square" lIns="0" tIns="0" rIns="0" bIns="0" rtlCol="0" anchor="ctr">
+            <a:normAutofit/>
+          </a:bodyPr>
+          <a:lstStyle/>
+          <a:p>
+            <a:pPr marL="0" indent="0">
+              <a:buNone/>
+            </a:pPr>
+            <a:r>
+              <a:rPr lang="ko-KR" sz="2500" b="1" dirty="0">
+                <a:solidFill>
+                  <a:srgbClr val="172033"/>
+                </a:solidFill>
+                <a:latin typeface="Aptos Display" pitchFamily="34" charset="0"/>
+                <a:ea typeface="Aptos Display" pitchFamily="34" charset="-122"/>
+              </a:rPr>
+              <a:t>보조 분석: Regression &amp; Clustering</a:t>
+            </a:r>
+          </a:p>
+        </p:txBody>
+      </p:sp>
+      <p:sp>
+        <p:nvSpPr>
+          <p:cNvPr id="10" name="RegBox"/>
+          <p:cNvSpPr/>
+          <p:nvPr/>
+        </p:nvSpPr>
+        <p:spPr>
+          <a:xfrm>
+            <a:off x="438912" y="1280160"/>
+            <a:ext cx="5486400" cy="5000000"/>
+          </a:xfrm>
+          <a:prstGeom prst="roundRect">
+            <a:avLst>
+              <a:gd name="adj" fmla="val 6838"/>
+            </a:avLst>
+          </a:prstGeom>
+          <a:solidFill>
+            <a:srgbClr val="FFFFFF"/>
+          </a:solidFill>
+          <a:ln w="12700">
+            <a:solidFill>
+              <a:srgbClr val="D9E1EC"/>
+            </a:solidFill>
+            <a:prstDash val="solid"/>
+          </a:ln>
+        </p:spPr>
+        <p:txBody>
+          <a:bodyPr/>
+          <a:lstStyle/>
+          <a:p>
+            <a:endParaRPr lang="ko-KR" altLang="en-US"/>
+          </a:p>
+        </p:txBody>
+      </p:sp>
+      <p:sp>
+        <p:nvSpPr>
+          <p:cNvPr id="11" name="RegTitle"/>
+          <p:cNvSpPr/>
+          <p:nvPr/>
+        </p:nvSpPr>
+        <p:spPr>
+          <a:xfrm>
+            <a:off x="657072" y="1390000"/>
+            <a:ext cx="5000000" cy="310896"/>
+          </a:xfrm>
+          <a:prstGeom prst="rect">
+            <a:avLst/>
+          </a:prstGeom>
+          <a:noFill/>
+          <a:ln/>
+        </p:spPr>
+        <p:txBody>
+          <a:bodyPr wrap="square" lIns="508" tIns="508" rIns="508" bIns="508" rtlCol="0" anchor="ctr">
+            <a:normAutofit/>
+          </a:bodyPr>
+          <a:lstStyle/>
+          <a:p>
+            <a:pPr marL="0" indent="0" algn="l">
+              <a:buNone/>
+            </a:pPr>
+            <a:r>
+              <a:rPr lang="ko-KR" sz="1600" b="1" dirty="0">
+                <a:solidFill>
+                  <a:srgbClr val="1D4ED8"/>
+                </a:solidFill>
+                <a:latin typeface="Aptos" pitchFamily="34" charset="0"/>
+                <a:ea typeface="Aptos" pitchFamily="34" charset="-122"/>
+              </a:rPr>
+              <a:t>Regression — Monthly_Balance 예측</a:t>
+            </a:r>
+          </a:p>
+        </p:txBody>
+      </p:sp>
+      <p:sp>
+        <p:nvSpPr>
+          <p:cNvPr id="12" name="RegDesc"/>
+          <p:cNvSpPr/>
+          <p:nvPr/>
+        </p:nvSpPr>
+        <p:spPr>
+          <a:xfrm>
+            <a:off x="657072" y="1780000"/>
+            <a:ext cx="5000000" cy="300000"/>
+          </a:xfrm>
+          <a:prstGeom prst="rect">
+            <a:avLst/>
+          </a:prstGeom>
+          <a:noFill/>
+          <a:ln/>
+        </p:spPr>
+        <p:txBody>
+          <a:bodyPr wrap="square" lIns="508" tIns="0" rIns="508" bIns="0" rtlCol="0" anchor="t">
+            <a:normAutofit/>
+          </a:bodyPr>
+          <a:lstStyle/>
+          <a:p>
+            <a:pPr marL="0" indent="0" algn="l">
+              <a:buNone/>
+            </a:pPr>
+            <a:r>
+              <a:rPr lang="ko-KR" sz="1400" dirty="0">
+                <a:solidFill>
+                  <a:srgbClr val="5B667A"/>
+                </a:solidFill>
+                <a:latin typeface="Aptos" pitchFamily="34" charset="0"/>
+                <a:ea typeface="Aptos" pitchFamily="34" charset="-122"/>
+              </a:rPr>
+              <a:t>나머지 feature로 월말 잔고를 예측하는 회귀 분석</a:t>
+            </a:r>
+          </a:p>
+        </p:txBody>
+      </p:sp>
+      <p:sp>
+        <p:nvSpPr>
+          <p:cNvPr id="13" name="RegTableHeader"/>
+          <p:cNvSpPr/>
+          <p:nvPr/>
+        </p:nvSpPr>
+        <p:spPr>
+          <a:xfrm>
+            <a:off x="657072" y="2150000"/>
+            <a:ext cx="5000000" cy="310896"/>
+          </a:xfrm>
+          <a:prstGeom prst="rect">
+            <a:avLst/>
+          </a:prstGeom>
+          <a:solidFill>
+            <a:srgbClr val="172033"/>
+          </a:solidFill>
+          <a:ln w="12700">
+            <a:solidFill>
+              <a:srgbClr val="172033"/>
+            </a:solidFill>
+            <a:prstDash val="solid"/>
+          </a:ln>
+        </p:spPr>
+        <p:txBody>
+          <a:bodyPr wrap="square" lIns="508" tIns="508" rIns="508" bIns="508" rtlCol="0" anchor="ctr">
+            <a:normAutofit/>
+          </a:bodyPr>
+          <a:lstStyle/>
+          <a:p>
+            <a:pPr marL="0" indent="0" algn="l">
+              <a:buNone/>
+            </a:pPr>
+            <a:r>
+              <a:rPr lang="en-US" sz="1100" b="1" dirty="0">
+                <a:solidFill>
+                  <a:srgbClr val="FFFFFF"/>
+                </a:solidFill>
+                <a:latin typeface="Aptos" pitchFamily="34" charset="0"/>
+              </a:rPr>
+              <a:t>Model                    R²          MAE</a:t>
+            </a:r>
+          </a:p>
+        </p:txBody>
+      </p:sp>
+      <p:sp>
+        <p:nvSpPr>
+          <p:cNvPr id="14" name="RegRow1"/>
+          <p:cNvSpPr/>
+          <p:nvPr/>
+        </p:nvSpPr>
+        <p:spPr>
+          <a:xfrm>
+            <a:off x="657072" y="2460896"/>
+            <a:ext cx="5000000" cy="300000"/>
+          </a:xfrm>
+          <a:prstGeom prst="rect">
+            <a:avLst/>
+          </a:prstGeom>
+          <a:solidFill>
+            <a:srgbClr val="F7F9FC"/>
+          </a:solidFill>
+          <a:ln w="12700">
+            <a:solidFill>
+              <a:srgbClr val="D9E1EC"/>
+            </a:solidFill>
+            <a:prstDash val="solid"/>
+          </a:ln>
+        </p:spPr>
+        <p:txBody>
+          <a:bodyPr wrap="square" lIns="508" tIns="508" rIns="508" bIns="508" rtlCol="0" anchor="ctr">
+            <a:normAutofit/>
+          </a:bodyPr>
+          <a:lstStyle/>
+          <a:p>
+            <a:pPr marL="0" indent="0" algn="l">
+              <a:buNone/>
+            </a:pPr>
+            <a:r>
+              <a:rPr lang="en-US" sz="1100" dirty="0">
+                <a:solidFill>
+                  <a:srgbClr val="172033"/>
+                </a:solidFill>
+                <a:latin typeface="Aptos" pitchFamily="34" charset="0"/>
+              </a:rPr>
+              <a:t>Ridge                        0.70        83.18</a:t>
+            </a:r>
+          </a:p>
+        </p:txBody>
+      </p:sp>
+      <p:sp>
+        <p:nvSpPr>
+          <p:cNvPr id="15" name="RegRow2"/>
+          <p:cNvSpPr/>
+          <p:nvPr/>
+        </p:nvSpPr>
+        <p:spPr>
+          <a:xfrm>
+            <a:off x="657072" y="2760896"/>
+            <a:ext cx="5000000" cy="300000"/>
+          </a:xfrm>
+          <a:prstGeom prst="rect">
+            <a:avLst/>
+          </a:prstGeom>
+          <a:solidFill>
+            <a:srgbClr val="E6F7F4"/>
+          </a:solidFill>
+          <a:ln w="12700">
+            <a:solidFill>
+              <a:srgbClr val="8DD8C9"/>
+            </a:solidFill>
+            <a:prstDash val="solid"/>
+          </a:ln>
+        </p:spPr>
+        <p:txBody>
+          <a:bodyPr wrap="square" lIns="508" tIns="508" rIns="508" bIns="508" rtlCol="0" anchor="ctr">
+            <a:normAutofit/>
+          </a:bodyPr>
+          <a:lstStyle/>
+          <a:p>
+            <a:pPr marL="0" indent="0" algn="l">
+              <a:buNone/>
+            </a:pPr>
+            <a:r>
+              <a:rPr lang="en-US" sz="1100" b="1" dirty="0">
+                <a:solidFill>
+                  <a:srgbClr val="0F766E"/>
+                </a:solidFill>
+                <a:latin typeface="Aptos" pitchFamily="34" charset="0"/>
+              </a:rPr>
+              <a:t>GradientBoosting     0.92 ★    33.14</a:t>
+            </a:r>
+          </a:p>
+        </p:txBody>
+      </p:sp>
+      <p:sp>
+        <p:nvSpPr>
+          <p:cNvPr id="16" name="RegConclusion"/>
+          <p:cNvSpPr/>
+          <p:nvPr/>
+        </p:nvSpPr>
+        <p:spPr>
+          <a:xfrm>
+            <a:off x="559552" y="3423657"/>
+            <a:ext cx="5000000" cy="310896"/>
+          </a:xfrm>
+          <a:prstGeom prst="rect">
+            <a:avLst/>
+          </a:prstGeom>
+          <a:noFill/>
+          <a:ln/>
+        </p:spPr>
+        <p:txBody>
+          <a:bodyPr wrap="square" lIns="508" tIns="0" rIns="508" bIns="0" rtlCol="0" anchor="t">
+            <a:normAutofit/>
+          </a:bodyPr>
+          <a:lstStyle/>
+          <a:p>
+            <a:pPr marL="0" indent="0" algn="l">
+              <a:buNone/>
+            </a:pPr>
+            <a:r>
+              <a:rPr lang="ko-KR" sz="1400" dirty="0">
+                <a:solidFill>
+                  <a:srgbClr val="5B667A"/>
+                </a:solidFill>
+                <a:latin typeface="Aptos" pitchFamily="34" charset="0"/>
+                <a:ea typeface="Aptos" pitchFamily="34" charset="-122"/>
+              </a:rPr>
+              <a:t>→ GradientBoosting이 R노 0.92로 월말 잔고의 92%를 설명</a:t>
+            </a:r>
+          </a:p>
+        </p:txBody>
+      </p:sp>
+      <p:sp>
+        <p:nvSpPr>
+          <p:cNvPr id="20" name="ClustBox"/>
+          <p:cNvSpPr/>
+          <p:nvPr/>
+        </p:nvSpPr>
+        <p:spPr>
+          <a:xfrm>
+            <a:off x="6205872" y="1280160"/>
+            <a:ext cx="5547168" cy="5000000"/>
+          </a:xfrm>
+          <a:prstGeom prst="roundRect">
+            <a:avLst>
+              <a:gd name="adj" fmla="val 6838"/>
+            </a:avLst>
+          </a:prstGeom>
+          <a:solidFill>
+            <a:srgbClr val="FFFFFF"/>
+          </a:solidFill>
+          <a:ln w="12700">
+            <a:solidFill>
+              <a:srgbClr val="D9E1EC"/>
+            </a:solidFill>
+            <a:prstDash val="solid"/>
+          </a:ln>
+        </p:spPr>
+        <p:txBody>
+          <a:bodyPr/>
+          <a:lstStyle/>
+          <a:p>
+            <a:endParaRPr lang="ko-KR" altLang="en-US" dirty="0"/>
+          </a:p>
+        </p:txBody>
+      </p:sp>
+      <p:sp>
+        <p:nvSpPr>
+          <p:cNvPr id="21" name="ClustTitle"/>
+          <p:cNvSpPr/>
+          <p:nvPr/>
+        </p:nvSpPr>
+        <p:spPr>
+          <a:xfrm>
+            <a:off x="6424032" y="1390000"/>
+            <a:ext cx="5100000" cy="310896"/>
+          </a:xfrm>
+          <a:prstGeom prst="rect">
+            <a:avLst/>
+          </a:prstGeom>
+          <a:noFill/>
+          <a:ln/>
+        </p:spPr>
+        <p:txBody>
+          <a:bodyPr wrap="square" lIns="508" tIns="508" rIns="508" bIns="508" rtlCol="0" anchor="ctr">
+            <a:normAutofit/>
+          </a:bodyPr>
+          <a:lstStyle/>
+          <a:p>
+            <a:pPr marL="0" indent="0" algn="l">
+              <a:buNone/>
+            </a:pPr>
+            <a:r>
+              <a:rPr lang="ko-KR" sz="1600" b="1" dirty="0">
+                <a:solidFill>
+                  <a:srgbClr val="1D4ED8"/>
+                </a:solidFill>
+                <a:latin typeface="Aptos" pitchFamily="34" charset="0"/>
+                <a:ea typeface="Aptos" pitchFamily="34" charset="-122"/>
+              </a:rPr>
+              <a:t>Clustering — 소비패턴 군집화</a:t>
+            </a:r>
+          </a:p>
+        </p:txBody>
+      </p:sp>
+      <p:sp>
+        <p:nvSpPr>
+          <p:cNvPr id="22" name="ClustDesc"/>
+          <p:cNvSpPr/>
+          <p:nvPr/>
+        </p:nvSpPr>
+        <p:spPr>
+          <a:xfrm>
+            <a:off x="6424032" y="1780000"/>
+            <a:ext cx="5100000" cy="300000"/>
+          </a:xfrm>
+          <a:prstGeom prst="rect">
+            <a:avLst/>
+          </a:prstGeom>
+          <a:noFill/>
+          <a:ln/>
+        </p:spPr>
+        <p:txBody>
+          <a:bodyPr wrap="square" lIns="508" tIns="0" rIns="508" bIns="0" rtlCol="0" anchor="t">
+            <a:normAutofit/>
+          </a:bodyPr>
+          <a:lstStyle/>
+          <a:p>
+            <a:pPr marL="0" indent="0" algn="l">
+              <a:buNone/>
+            </a:pPr>
+            <a:r>
+              <a:rPr lang="ko-KR" sz="1400" dirty="0">
+                <a:solidFill>
+                  <a:srgbClr val="5B667A"/>
+                </a:solidFill>
+                <a:latin typeface="Aptos" pitchFamily="34" charset="0"/>
+                <a:ea typeface="Aptos" pitchFamily="34" charset="-122"/>
+              </a:rPr>
+              <a:t>KMeans(k=4) 소비/저축 변수 7개로 고객 군집화</a:t>
+            </a:r>
+          </a:p>
+        </p:txBody>
+      </p:sp>
+      <p:sp>
+        <p:nvSpPr>
+          <p:cNvPr id="24" name="ClustConclusion"/>
+          <p:cNvSpPr/>
+          <p:nvPr/>
+        </p:nvSpPr>
+        <p:spPr>
+          <a:xfrm>
+            <a:off x="6424032" y="5050000"/>
+            <a:ext cx="5100000" cy="310896"/>
+          </a:xfrm>
+          <a:prstGeom prst="rect">
+            <a:avLst/>
+          </a:prstGeom>
+          <a:noFill/>
+          <a:ln/>
+        </p:spPr>
+        <p:txBody>
+          <a:bodyPr wrap="square" lIns="508" tIns="0" rIns="508" bIns="0" rtlCol="0" anchor="t">
+            <a:normAutofit/>
+          </a:bodyPr>
+          <a:lstStyle/>
+          <a:p>
+            <a:r>
+              <a:rPr lang="ko-KR" sz="1400" dirty="0">
+                <a:solidFill>
+                  <a:schemeClr val="tx1">
+                    <a:lumMod val="50000"/>
+                    <a:lumOff val="50000"/>
+                  </a:schemeClr>
+                </a:solidFill>
+                <a:latin typeface="Aptos" pitchFamily="34" charset="0"/>
+                <a:ea typeface="Aptos" pitchFamily="34" charset="-122"/>
+              </a:rPr>
+              <a:t>→ </a:t>
+            </a:r>
+            <a:r>
+              <a:rPr lang="en-US" altLang="ko-KR" sz="1400" dirty="0">
+                <a:solidFill>
+                  <a:schemeClr val="tx1">
+                    <a:lumMod val="50000"/>
+                    <a:lumOff val="50000"/>
+                  </a:schemeClr>
+                </a:solidFill>
+              </a:rPr>
+              <a:t>k=5</a:t>
+            </a:r>
+            <a:r>
+              <a:rPr lang="ko-KR" altLang="en-US" sz="1400" dirty="0">
+                <a:solidFill>
+                  <a:schemeClr val="tx1">
+                    <a:lumMod val="50000"/>
+                    <a:lumOff val="50000"/>
+                  </a:schemeClr>
+                </a:solidFill>
+              </a:rPr>
+              <a:t>일 때 </a:t>
+            </a:r>
+            <a:r>
+              <a:rPr lang="en-US" altLang="ko-KR" sz="1400" dirty="0">
+                <a:solidFill>
+                  <a:schemeClr val="tx1">
+                    <a:lumMod val="50000"/>
+                    <a:lumOff val="50000"/>
+                  </a:schemeClr>
+                </a:solidFill>
+              </a:rPr>
+              <a:t>Silhouette </a:t>
+            </a:r>
+            <a:r>
+              <a:rPr lang="ko-KR" altLang="en-US" sz="1400" dirty="0">
+                <a:solidFill>
+                  <a:schemeClr val="tx1">
+                    <a:lumMod val="50000"/>
+                    <a:lumOff val="50000"/>
+                  </a:schemeClr>
+                </a:solidFill>
+              </a:rPr>
+              <a:t>최고</a:t>
+            </a:r>
+            <a:r>
+              <a:rPr lang="en-US" altLang="ko-KR" sz="1400" dirty="0">
+                <a:solidFill>
+                  <a:schemeClr val="tx1">
+                    <a:lumMod val="50000"/>
+                    <a:lumOff val="50000"/>
+                  </a:schemeClr>
+                </a:solidFill>
+              </a:rPr>
+              <a:t>(0.37), elbow </a:t>
+            </a:r>
+            <a:r>
+              <a:rPr lang="ko-KR" altLang="en-US" sz="1400" dirty="0">
+                <a:solidFill>
+                  <a:schemeClr val="tx1">
+                    <a:lumMod val="50000"/>
+                    <a:lumOff val="50000"/>
+                  </a:schemeClr>
+                </a:solidFill>
+              </a:rPr>
+              <a:t>기준으로 </a:t>
+            </a:r>
+            <a:r>
+              <a:rPr lang="en-US" altLang="ko-KR" sz="1400" dirty="0">
+                <a:solidFill>
+                  <a:schemeClr val="tx1">
+                    <a:lumMod val="50000"/>
+                    <a:lumOff val="50000"/>
+                  </a:schemeClr>
+                </a:solidFill>
+              </a:rPr>
+              <a:t>k=4 </a:t>
+            </a:r>
+            <a:r>
+              <a:rPr lang="ko-KR" altLang="en-US" sz="1400" dirty="0">
+                <a:solidFill>
+                  <a:schemeClr val="tx1">
+                    <a:lumMod val="50000"/>
+                    <a:lumOff val="50000"/>
+                  </a:schemeClr>
+                </a:solidFill>
+              </a:rPr>
+              <a:t>선택</a:t>
+            </a:r>
+            <a:endParaRPr lang="ko-KR" sz="1400" dirty="0">
+              <a:solidFill>
+                <a:schemeClr val="tx1">
+                  <a:lumMod val="50000"/>
+                  <a:lumOff val="50000"/>
+                </a:schemeClr>
+              </a:solidFill>
+              <a:latin typeface="Aptos" pitchFamily="34" charset="0"/>
+              <a:ea typeface="Aptos" pitchFamily="34" charset="-122"/>
+            </a:endParaRPr>
+          </a:p>
+        </p:txBody>
+      </p:sp>
+      <p:pic>
+        <p:nvPicPr>
+          <p:cNvPr id="7" name="그림 6">
+            <a:extLst>
+              <a:ext uri="{FF2B5EF4-FFF2-40B4-BE49-F238E27FC236}">
+                <a16:creationId xmlns:a16="http://schemas.microsoft.com/office/drawing/2014/main" id="{F1135909-33F0-4F18-9A53-7318C2BCBABB}"/>
+              </a:ext>
+            </a:extLst>
+          </p:cNvPr>
+          <p:cNvPicPr>
+            <a:picLocks noChangeAspect="1"/>
+          </p:cNvPicPr>
+          <p:nvPr/>
+        </p:nvPicPr>
+        <p:blipFill>
+          <a:blip r:embed="rId2"/>
+          <a:stretch>
+            <a:fillRect/>
+          </a:stretch>
+        </p:blipFill>
+        <p:spPr>
+          <a:xfrm>
+            <a:off x="6424032" y="2051151"/>
+            <a:ext cx="4150867" cy="2619745"/>
+          </a:xfrm>
+          <a:prstGeom prst="rect">
+            <a:avLst/>
+          </a:prstGeom>
+        </p:spPr>
+      </p:pic>
+    </p:spTree>
+  </p:cSld>
+  <p:clrMapOvr>
+    <a:masterClrMapping/>
+  </p:clrMapOvr>
+</p:sld>
+</file>
+
+<file path=ppt/slides/slide18.xml><?xml version="1.0" encoding="utf-8"?>
+<p:sld xmlns:a="http://schemas.openxmlformats.org/drawingml/2006/main" xmlns:r="http://schemas.openxmlformats.org/officeDocument/2006/relationships" xmlns:p="http://schemas.openxmlformats.org/presentationml/2006/main">
+  <p:cSld>
+    <p:spTree>
+      <p:nvGrpSpPr>
+        <p:cNvPr id="1" name=""/>
+        <p:cNvGrpSpPr/>
+        <p:nvPr/>
+      </p:nvGrpSpPr>
+      <p:grpSpPr>
+        <a:xfrm>
+          <a:off x="0" y="0"/>
+          <a:ext cx="0" cy="0"/>
+          <a:chOff x="0" y="0"/>
+          <a:chExt cx="0" cy="0"/>
+        </a:xfrm>
+      </p:grpSpPr>
+      <p:sp>
+        <p:nvSpPr>
+          <p:cNvPr id="2" name="Text 0"/>
+          <p:cNvSpPr/>
+          <p:nvPr/>
+        </p:nvSpPr>
+        <p:spPr>
+          <a:xfrm>
+            <a:off x="457200" y="365760"/>
+            <a:ext cx="7315200" cy="274320"/>
+          </a:xfrm>
+          <a:prstGeom prst="rect">
+            <a:avLst/>
+          </a:prstGeom>
+          <a:noFill/>
+          <a:ln/>
+        </p:spPr>
+        <p:txBody>
+          <a:bodyPr wrap="square" lIns="0" tIns="0" rIns="0" bIns="0" rtlCol="0" anchor="ctr"/>
+          <a:lstStyle/>
+          <a:p>
+            <a:pPr marL="0" indent="0">
+              <a:buNone/>
+            </a:pPr>
+            <a:r>
+              <a:rPr lang="en-US" sz="1200" dirty="0">
+                <a:solidFill>
+                  <a:srgbClr val="8E8E93"/>
+                </a:solidFill>
+                <a:latin typeface="Pretendard" pitchFamily="34" charset="0"/>
+                <a:ea typeface="Pretendard" pitchFamily="34" charset="-122"/>
+                <a:cs typeface="Pretendard" pitchFamily="34" charset="-120"/>
+              </a:rPr>
+              <a:t>08 Learning Experience</a:t>
+            </a:r>
+            <a:endParaRPr lang="en-US" sz="1200" dirty="0"/>
+          </a:p>
+        </p:txBody>
+      </p:sp>
+      <p:sp>
+        <p:nvSpPr>
+          <p:cNvPr id="3" name="Text 1"/>
+          <p:cNvSpPr/>
+          <p:nvPr/>
+        </p:nvSpPr>
+        <p:spPr>
+          <a:xfrm>
+            <a:off x="420624" y="543269"/>
+            <a:ext cx="11277295" cy="685800"/>
+          </a:xfrm>
+          <a:prstGeom prst="rect">
+            <a:avLst/>
+          </a:prstGeom>
+          <a:noFill/>
+          <a:ln/>
+        </p:spPr>
+        <p:txBody>
+          <a:bodyPr wrap="square" lIns="0" tIns="0" rIns="0" bIns="0" rtlCol="0" anchor="ctr"/>
+          <a:lstStyle/>
+          <a:p>
+            <a:pPr marL="0" indent="0">
+              <a:lnSpc>
+                <a:spcPct val="120000"/>
+              </a:lnSpc>
+              <a:buNone/>
+            </a:pPr>
+            <a:r>
+              <a:rPr lang="en-US" sz="3600" b="1" dirty="0">
+                <a:solidFill>
+                  <a:srgbClr val="222222"/>
+                </a:solidFill>
+                <a:latin typeface="Pretendard" pitchFamily="34" charset="0"/>
+                <a:ea typeface="Pretendard" pitchFamily="34" charset="-122"/>
+                <a:cs typeface="Pretendard" pitchFamily="34" charset="-120"/>
+              </a:rPr>
+              <a:t>Learning Experience</a:t>
+            </a:r>
+            <a:endParaRPr lang="en-US" sz="3600" dirty="0"/>
+          </a:p>
+        </p:txBody>
+      </p:sp>
+      <p:sp>
+        <p:nvSpPr>
+          <p:cNvPr id="4" name="Text 2"/>
+          <p:cNvSpPr/>
+          <p:nvPr/>
+        </p:nvSpPr>
+        <p:spPr>
+          <a:xfrm>
+            <a:off x="429768" y="1142999"/>
+            <a:ext cx="11277295" cy="365760"/>
+          </a:xfrm>
+          <a:prstGeom prst="rect">
+            <a:avLst/>
+          </a:prstGeom>
+          <a:noFill/>
+          <a:ln/>
+        </p:spPr>
+        <p:txBody>
+          <a:bodyPr wrap="square" lIns="0" tIns="0" rIns="0" bIns="0" rtlCol="0" anchor="ctr"/>
+          <a:lstStyle/>
+          <a:p>
+            <a:pPr marL="0" indent="0">
+              <a:lnSpc>
+                <a:spcPct val="145000"/>
+              </a:lnSpc>
+              <a:buNone/>
+            </a:pPr>
+            <a:r>
+              <a:rPr lang="en-US" sz="1600" dirty="0">
+                <a:solidFill>
+                  <a:srgbClr val="45515E"/>
+                </a:solidFill>
+                <a:latin typeface="Pretendard" pitchFamily="34" charset="0"/>
+                <a:ea typeface="Pretendard" pitchFamily="34" charset="-122"/>
+                <a:cs typeface="Pretendard" pitchFamily="34" charset="-120"/>
+              </a:rPr>
+              <a:t>프로젝트를 수행하며 얻은 핵심 인사이트와 개선 경험</a:t>
+            </a:r>
+            <a:endParaRPr lang="en-US" sz="1600" dirty="0"/>
+          </a:p>
+        </p:txBody>
+      </p:sp>
+      <p:sp>
+        <p:nvSpPr>
+          <p:cNvPr id="5" name="Shape 3"/>
+          <p:cNvSpPr/>
+          <p:nvPr/>
+        </p:nvSpPr>
+        <p:spPr>
+          <a:xfrm>
+            <a:off x="457200" y="2185416"/>
+            <a:ext cx="5394960" cy="3374136"/>
+          </a:xfrm>
+          <a:prstGeom prst="roundRect">
+            <a:avLst>
+              <a:gd name="adj" fmla="val 3523"/>
+            </a:avLst>
+          </a:prstGeom>
+          <a:solidFill>
+            <a:srgbClr val="FFFFFF"/>
+          </a:solidFill>
+          <a:ln w="19050">
+            <a:solidFill>
+              <a:srgbClr val="FCD34D"/>
+            </a:solidFill>
+            <a:prstDash val="solid"/>
+          </a:ln>
+          <a:effectLst>
+            <a:outerShdw blurRad="101600" dist="50800" dir="8100000" algn="bl" rotWithShape="0">
+              <a:srgbClr val="000000">
+                <a:alpha val="8000"/>
+              </a:srgbClr>
+            </a:outerShdw>
+          </a:effectLst>
+        </p:spPr>
+      </p:sp>
+      <p:sp>
+        <p:nvSpPr>
+          <p:cNvPr id="6" name="Shape 4"/>
+          <p:cNvSpPr/>
+          <p:nvPr/>
+        </p:nvSpPr>
+        <p:spPr>
+          <a:xfrm>
+            <a:off x="457200" y="2185416"/>
+            <a:ext cx="64008" cy="3374136"/>
+          </a:xfrm>
+          <a:prstGeom prst="rect">
+            <a:avLst/>
+          </a:prstGeom>
+          <a:solidFill>
+            <a:srgbClr val="D97706"/>
+          </a:solidFill>
+          <a:ln/>
+        </p:spPr>
+      </p:sp>
+      <p:sp>
+        <p:nvSpPr>
+          <p:cNvPr id="7" name="Text 5"/>
+          <p:cNvSpPr/>
+          <p:nvPr/>
+        </p:nvSpPr>
+        <p:spPr>
+          <a:xfrm>
+            <a:off x="658368" y="2340864"/>
+            <a:ext cx="5074920" cy="274320"/>
+          </a:xfrm>
+          <a:prstGeom prst="rect">
+            <a:avLst/>
+          </a:prstGeom>
+          <a:noFill/>
+          <a:ln/>
+        </p:spPr>
+        <p:txBody>
+          <a:bodyPr wrap="square" lIns="0" tIns="0" rIns="0" bIns="0" rtlCol="0" anchor="ctr"/>
+          <a:lstStyle/>
+          <a:p>
+            <a:pPr marL="0" indent="0">
+              <a:buNone/>
+            </a:pPr>
+            <a:r>
+              <a:rPr lang="en-US" sz="1400" b="1" dirty="0">
+                <a:solidFill>
+                  <a:srgbClr val="D97706"/>
+                </a:solidFill>
+                <a:latin typeface="Pretendard" pitchFamily="34" charset="0"/>
+                <a:ea typeface="Pretendard" pitchFamily="34" charset="-122"/>
+                <a:cs typeface="Pretendard" pitchFamily="34" charset="-120"/>
+              </a:rPr>
+              <a:t>어려움과 해결</a:t>
+            </a:r>
+            <a:endParaRPr lang="en-US" sz="1400" dirty="0"/>
+          </a:p>
+        </p:txBody>
+      </p:sp>
+      <p:sp>
+        <p:nvSpPr>
+          <p:cNvPr id="8" name="Shape 6"/>
+          <p:cNvSpPr/>
+          <p:nvPr/>
+        </p:nvSpPr>
+        <p:spPr>
+          <a:xfrm>
+            <a:off x="658368" y="2688336"/>
+            <a:ext cx="4992624" cy="0"/>
+          </a:xfrm>
+          <a:prstGeom prst="line">
+            <a:avLst/>
+          </a:prstGeom>
+          <a:noFill/>
+          <a:ln w="12700">
+            <a:solidFill>
+              <a:srgbClr val="FCD34D"/>
+            </a:solidFill>
+            <a:prstDash val="solid"/>
+          </a:ln>
+        </p:spPr>
+      </p:sp>
+      <p:sp>
+        <p:nvSpPr>
+          <p:cNvPr id="9" name="Shape 7"/>
+          <p:cNvSpPr/>
+          <p:nvPr/>
+        </p:nvSpPr>
+        <p:spPr>
+          <a:xfrm>
+            <a:off x="658368" y="2862072"/>
+            <a:ext cx="274320" cy="256032"/>
+          </a:xfrm>
+          <a:prstGeom prst="roundRect">
+            <a:avLst>
+              <a:gd name="adj" fmla="val 17857"/>
+            </a:avLst>
+          </a:prstGeom>
+          <a:solidFill>
+            <a:srgbClr val="FFFBEB"/>
+          </a:solidFill>
+          <a:ln w="12700">
+            <a:solidFill>
+              <a:srgbClr val="FCD34D"/>
+            </a:solidFill>
+            <a:prstDash val="solid"/>
+          </a:ln>
+        </p:spPr>
+      </p:sp>
+      <p:sp>
+        <p:nvSpPr>
+          <p:cNvPr id="10" name="Text 8"/>
+          <p:cNvSpPr/>
+          <p:nvPr/>
+        </p:nvSpPr>
+        <p:spPr>
+          <a:xfrm>
+            <a:off x="658368" y="2862072"/>
+            <a:ext cx="274320" cy="256032"/>
+          </a:xfrm>
+          <a:prstGeom prst="rect">
+            <a:avLst/>
+          </a:prstGeom>
+          <a:noFill/>
+          <a:ln/>
+        </p:spPr>
+        <p:txBody>
+          <a:bodyPr wrap="square" lIns="0" tIns="0" rIns="0" bIns="0" rtlCol="0" anchor="ctr"/>
+          <a:lstStyle/>
+          <a:p>
+            <a:pPr marL="0" indent="0" algn="ctr">
+              <a:buNone/>
+            </a:pPr>
+            <a:r>
+              <a:rPr lang="en-US" sz="1000" b="1" dirty="0">
+                <a:solidFill>
+                  <a:srgbClr val="D97706"/>
+                </a:solidFill>
+                <a:latin typeface="Pretendard" pitchFamily="34" charset="0"/>
+                <a:ea typeface="Pretendard" pitchFamily="34" charset="-122"/>
+                <a:cs typeface="Pretendard" pitchFamily="34" charset="-120"/>
+              </a:rPr>
+              <a:t>01</a:t>
+            </a:r>
+            <a:endParaRPr lang="en-US" sz="1000" dirty="0"/>
+          </a:p>
+        </p:txBody>
+      </p:sp>
+      <p:sp>
+        <p:nvSpPr>
+          <p:cNvPr id="11" name="Text 9"/>
+          <p:cNvSpPr/>
+          <p:nvPr/>
+        </p:nvSpPr>
+        <p:spPr>
+          <a:xfrm>
+            <a:off x="1005840" y="2862072"/>
+            <a:ext cx="4718304" cy="256032"/>
+          </a:xfrm>
+          <a:prstGeom prst="rect">
+            <a:avLst/>
+          </a:prstGeom>
+          <a:noFill/>
+          <a:ln/>
+        </p:spPr>
+        <p:txBody>
+          <a:bodyPr wrap="square" lIns="0" tIns="0" rIns="0" bIns="0" rtlCol="0" anchor="ctr"/>
+          <a:lstStyle/>
+          <a:p>
+            <a:pPr marL="0" indent="0">
+              <a:buNone/>
+            </a:pPr>
+            <a:r>
+              <a:rPr lang="en-US" sz="1200" b="1" dirty="0">
+                <a:solidFill>
+                  <a:srgbClr val="222222"/>
+                </a:solidFill>
+                <a:latin typeface="Pretendard" pitchFamily="34" charset="0"/>
+                <a:ea typeface="Pretendard" pitchFamily="34" charset="-122"/>
+                <a:cs typeface="Pretendard" pitchFamily="34" charset="-120"/>
+              </a:rPr>
+              <a:t>Windows SMOTE OpenMP 충돌</a:t>
+            </a:r>
+            <a:endParaRPr lang="en-US" sz="1200" dirty="0"/>
+          </a:p>
+        </p:txBody>
+      </p:sp>
+      <p:sp>
+        <p:nvSpPr>
+          <p:cNvPr id="12" name="Shape 10"/>
+          <p:cNvSpPr/>
+          <p:nvPr/>
+        </p:nvSpPr>
+        <p:spPr>
+          <a:xfrm>
+            <a:off x="658368" y="3191256"/>
+            <a:ext cx="4992624" cy="420624"/>
+          </a:xfrm>
+          <a:prstGeom prst="roundRect">
+            <a:avLst>
+              <a:gd name="adj" fmla="val 13043"/>
+            </a:avLst>
+          </a:prstGeom>
+          <a:solidFill>
+            <a:srgbClr val="FFFBEB"/>
+          </a:solidFill>
+          <a:ln w="9525">
+            <a:solidFill>
+              <a:srgbClr val="FCD34D"/>
+            </a:solidFill>
+            <a:prstDash val="solid"/>
+          </a:ln>
+        </p:spPr>
+      </p:sp>
+      <p:sp>
+        <p:nvSpPr>
+          <p:cNvPr id="13" name="Text 11"/>
+          <p:cNvSpPr/>
+          <p:nvPr/>
+        </p:nvSpPr>
+        <p:spPr>
+          <a:xfrm>
+            <a:off x="749808" y="3191256"/>
+            <a:ext cx="4882896" cy="420624"/>
+          </a:xfrm>
+          <a:prstGeom prst="rect">
+            <a:avLst/>
+          </a:prstGeom>
+          <a:noFill/>
+          <a:ln/>
+        </p:spPr>
+        <p:txBody>
+          <a:bodyPr wrap="square" lIns="0" tIns="0" rIns="0" bIns="0" rtlCol="0" anchor="ctr"/>
+          <a:lstStyle/>
+          <a:p>
+            <a:pPr marL="0" indent="0">
+              <a:lnSpc>
+                <a:spcPct val="130000"/>
+              </a:lnSpc>
+              <a:buNone/>
+            </a:pPr>
+            <a:r>
+              <a:rPr lang="en-US" sz="1050" dirty="0">
+                <a:solidFill>
+                  <a:srgbClr val="45515E"/>
+                </a:solidFill>
+                <a:latin typeface="Pretendard" pitchFamily="34" charset="0"/>
+                <a:ea typeface="Pretendard" pitchFamily="34" charset="-122"/>
+                <a:cs typeface="Pretendard" pitchFamily="34" charset="-120"/>
+              </a:rPr>
+              <a:t>→  environment.yml에 llvm-openmp / intel-openmp 명시적 포함으로 해결</a:t>
+            </a:r>
+            <a:endParaRPr lang="en-US" sz="1050" dirty="0"/>
+          </a:p>
+        </p:txBody>
+      </p:sp>
+      <p:sp>
+        <p:nvSpPr>
+          <p:cNvPr id="14" name="Shape 12"/>
+          <p:cNvSpPr/>
+          <p:nvPr/>
+        </p:nvSpPr>
+        <p:spPr>
+          <a:xfrm>
+            <a:off x="658368" y="3749040"/>
+            <a:ext cx="274320" cy="256032"/>
+          </a:xfrm>
+          <a:prstGeom prst="roundRect">
+            <a:avLst>
+              <a:gd name="adj" fmla="val 17857"/>
+            </a:avLst>
+          </a:prstGeom>
+          <a:solidFill>
+            <a:srgbClr val="FFFBEB"/>
+          </a:solidFill>
+          <a:ln w="12700">
+            <a:solidFill>
+              <a:srgbClr val="FCD34D"/>
+            </a:solidFill>
+            <a:prstDash val="solid"/>
+          </a:ln>
+        </p:spPr>
+      </p:sp>
+      <p:sp>
+        <p:nvSpPr>
+          <p:cNvPr id="15" name="Text 13"/>
+          <p:cNvSpPr/>
+          <p:nvPr/>
+        </p:nvSpPr>
+        <p:spPr>
+          <a:xfrm>
+            <a:off x="658368" y="3749040"/>
+            <a:ext cx="274320" cy="256032"/>
+          </a:xfrm>
+          <a:prstGeom prst="rect">
+            <a:avLst/>
+          </a:prstGeom>
+          <a:noFill/>
+          <a:ln/>
+        </p:spPr>
+        <p:txBody>
+          <a:bodyPr wrap="square" lIns="0" tIns="0" rIns="0" bIns="0" rtlCol="0" anchor="ctr"/>
+          <a:lstStyle/>
+          <a:p>
+            <a:pPr marL="0" indent="0" algn="ctr">
+              <a:buNone/>
+            </a:pPr>
+            <a:r>
+              <a:rPr lang="en-US" sz="1000" b="1" dirty="0">
+                <a:solidFill>
+                  <a:srgbClr val="D97706"/>
+                </a:solidFill>
+                <a:latin typeface="Pretendard" pitchFamily="34" charset="0"/>
+                <a:ea typeface="Pretendard" pitchFamily="34" charset="-122"/>
+                <a:cs typeface="Pretendard" pitchFamily="34" charset="-120"/>
+              </a:rPr>
+              <a:t>02</a:t>
+            </a:r>
+            <a:endParaRPr lang="en-US" sz="1000" dirty="0"/>
+          </a:p>
+        </p:txBody>
+      </p:sp>
+      <p:sp>
+        <p:nvSpPr>
+          <p:cNvPr id="16" name="Text 14"/>
+          <p:cNvSpPr/>
+          <p:nvPr/>
+        </p:nvSpPr>
+        <p:spPr>
+          <a:xfrm>
+            <a:off x="1005840" y="3749040"/>
+            <a:ext cx="4718304" cy="256032"/>
+          </a:xfrm>
+          <a:prstGeom prst="rect">
+            <a:avLst/>
+          </a:prstGeom>
+          <a:noFill/>
+          <a:ln/>
+        </p:spPr>
+        <p:txBody>
+          <a:bodyPr wrap="square" lIns="0" tIns="0" rIns="0" bIns="0" rtlCol="0" anchor="ctr"/>
+          <a:lstStyle/>
+          <a:p>
+            <a:pPr marL="0" indent="0">
+              <a:buNone/>
+            </a:pPr>
+            <a:r>
+              <a:rPr lang="en-US" sz="1200" b="1" dirty="0">
+                <a:solidFill>
+                  <a:srgbClr val="222222"/>
+                </a:solidFill>
+                <a:latin typeface="Pretendard" pitchFamily="34" charset="0"/>
+                <a:ea typeface="Pretendard" pitchFamily="34" charset="-122"/>
+                <a:cs typeface="Pretendard" pitchFamily="34" charset="-120"/>
+              </a:rPr>
+              <a:t>Dirty data 전처리의 복잡성</a:t>
+            </a:r>
+            <a:endParaRPr lang="en-US" sz="1200" dirty="0"/>
+          </a:p>
+        </p:txBody>
+      </p:sp>
+      <p:sp>
+        <p:nvSpPr>
+          <p:cNvPr id="17" name="Shape 15"/>
+          <p:cNvSpPr/>
+          <p:nvPr/>
+        </p:nvSpPr>
+        <p:spPr>
+          <a:xfrm>
+            <a:off x="658368" y="4078224"/>
+            <a:ext cx="4992624" cy="420624"/>
+          </a:xfrm>
+          <a:prstGeom prst="roundRect">
+            <a:avLst>
+              <a:gd name="adj" fmla="val 13043"/>
+            </a:avLst>
+          </a:prstGeom>
+          <a:solidFill>
+            <a:srgbClr val="FFFBEB"/>
+          </a:solidFill>
+          <a:ln w="9525">
+            <a:solidFill>
+              <a:srgbClr val="FCD34D"/>
+            </a:solidFill>
+            <a:prstDash val="solid"/>
+          </a:ln>
+        </p:spPr>
+      </p:sp>
+      <p:sp>
+        <p:nvSpPr>
+          <p:cNvPr id="18" name="Text 16"/>
+          <p:cNvSpPr/>
+          <p:nvPr/>
+        </p:nvSpPr>
+        <p:spPr>
+          <a:xfrm>
+            <a:off x="749808" y="4078224"/>
+            <a:ext cx="4882896" cy="420624"/>
+          </a:xfrm>
+          <a:prstGeom prst="rect">
+            <a:avLst/>
+          </a:prstGeom>
+          <a:noFill/>
+          <a:ln/>
+        </p:spPr>
+        <p:txBody>
+          <a:bodyPr wrap="square" lIns="0" tIns="0" rIns="0" bIns="0" rtlCol="0" anchor="ctr"/>
+          <a:lstStyle/>
+          <a:p>
+            <a:pPr marL="0" indent="0">
+              <a:lnSpc>
+                <a:spcPct val="130000"/>
+              </a:lnSpc>
+              <a:buNone/>
+            </a:pPr>
+            <a:r>
+              <a:rPr lang="en-US" sz="1050" dirty="0">
+                <a:solidFill>
+                  <a:srgbClr val="45515E"/>
+                </a:solidFill>
+                <a:latin typeface="Pretendard" pitchFamily="34" charset="0"/>
+                <a:ea typeface="Pretendard" pitchFamily="34" charset="-122"/>
+                <a:cs typeface="Pretendard" pitchFamily="34" charset="-120"/>
+              </a:rPr>
+              <a:t>→  placeholder / underscore / domain cutoff 9단계 파이프라인으로 체계화</a:t>
+            </a:r>
+            <a:endParaRPr lang="en-US" sz="1050" dirty="0"/>
+          </a:p>
+        </p:txBody>
+      </p:sp>
+      <p:sp>
+        <p:nvSpPr>
+          <p:cNvPr id="19" name="Shape 17"/>
+          <p:cNvSpPr/>
+          <p:nvPr/>
+        </p:nvSpPr>
+        <p:spPr>
+          <a:xfrm>
+            <a:off x="658368" y="4636008"/>
+            <a:ext cx="274320" cy="256032"/>
+          </a:xfrm>
+          <a:prstGeom prst="roundRect">
+            <a:avLst>
+              <a:gd name="adj" fmla="val 17857"/>
+            </a:avLst>
+          </a:prstGeom>
+          <a:solidFill>
+            <a:srgbClr val="FFFBEB"/>
+          </a:solidFill>
+          <a:ln w="12700">
+            <a:solidFill>
+              <a:srgbClr val="FCD34D"/>
+            </a:solidFill>
+            <a:prstDash val="solid"/>
+          </a:ln>
+        </p:spPr>
+      </p:sp>
+      <p:sp>
+        <p:nvSpPr>
+          <p:cNvPr id="20" name="Text 18"/>
+          <p:cNvSpPr/>
+          <p:nvPr/>
+        </p:nvSpPr>
+        <p:spPr>
+          <a:xfrm>
+            <a:off x="658368" y="4636008"/>
+            <a:ext cx="274320" cy="256032"/>
+          </a:xfrm>
+          <a:prstGeom prst="rect">
+            <a:avLst/>
+          </a:prstGeom>
+          <a:noFill/>
+          <a:ln/>
+        </p:spPr>
+        <p:txBody>
+          <a:bodyPr wrap="square" lIns="0" tIns="0" rIns="0" bIns="0" rtlCol="0" anchor="ctr"/>
+          <a:lstStyle/>
+          <a:p>
+            <a:pPr marL="0" indent="0" algn="ctr">
+              <a:buNone/>
+            </a:pPr>
+            <a:r>
+              <a:rPr lang="en-US" sz="1000" b="1" dirty="0">
+                <a:solidFill>
+                  <a:srgbClr val="D97706"/>
+                </a:solidFill>
+                <a:latin typeface="Pretendard" pitchFamily="34" charset="0"/>
+                <a:ea typeface="Pretendard" pitchFamily="34" charset="-122"/>
+                <a:cs typeface="Pretendard" pitchFamily="34" charset="-120"/>
+              </a:rPr>
+              <a:t>03</a:t>
+            </a:r>
+            <a:endParaRPr lang="en-US" sz="1000" dirty="0"/>
+          </a:p>
+        </p:txBody>
+      </p:sp>
+      <p:sp>
+        <p:nvSpPr>
+          <p:cNvPr id="21" name="Text 19"/>
+          <p:cNvSpPr/>
+          <p:nvPr/>
+        </p:nvSpPr>
+        <p:spPr>
+          <a:xfrm>
+            <a:off x="1005840" y="4636008"/>
+            <a:ext cx="4718304" cy="256032"/>
+          </a:xfrm>
+          <a:prstGeom prst="rect">
+            <a:avLst/>
+          </a:prstGeom>
+          <a:noFill/>
+          <a:ln/>
+        </p:spPr>
+        <p:txBody>
+          <a:bodyPr wrap="square" lIns="0" tIns="0" rIns="0" bIns="0" rtlCol="0" anchor="ctr"/>
+          <a:lstStyle/>
+          <a:p>
+            <a:pPr marL="0" indent="0">
+              <a:buNone/>
+            </a:pPr>
+            <a:r>
+              <a:rPr lang="en-US" sz="1200" b="1" dirty="0">
+                <a:solidFill>
+                  <a:srgbClr val="222222"/>
+                </a:solidFill>
+                <a:latin typeface="Pretendard" pitchFamily="34" charset="0"/>
+                <a:ea typeface="Pretendard" pitchFamily="34" charset="-122"/>
+                <a:cs typeface="Pretendard" pitchFamily="34" charset="-120"/>
+              </a:rPr>
+              <a:t>노트북 → 패키지화</a:t>
+            </a:r>
+            <a:endParaRPr lang="en-US" sz="1200" dirty="0"/>
+          </a:p>
+        </p:txBody>
+      </p:sp>
+      <p:sp>
+        <p:nvSpPr>
+          <p:cNvPr id="22" name="Shape 20"/>
+          <p:cNvSpPr/>
+          <p:nvPr/>
+        </p:nvSpPr>
+        <p:spPr>
+          <a:xfrm>
+            <a:off x="658368" y="4965192"/>
+            <a:ext cx="4992624" cy="420624"/>
+          </a:xfrm>
+          <a:prstGeom prst="roundRect">
+            <a:avLst>
+              <a:gd name="adj" fmla="val 13043"/>
+            </a:avLst>
+          </a:prstGeom>
+          <a:solidFill>
+            <a:srgbClr val="FFFBEB"/>
+          </a:solidFill>
+          <a:ln w="9525">
+            <a:solidFill>
+              <a:srgbClr val="FCD34D"/>
+            </a:solidFill>
+            <a:prstDash val="solid"/>
+          </a:ln>
+        </p:spPr>
+      </p:sp>
+      <p:sp>
+        <p:nvSpPr>
+          <p:cNvPr id="23" name="Text 21"/>
+          <p:cNvSpPr/>
+          <p:nvPr/>
+        </p:nvSpPr>
+        <p:spPr>
+          <a:xfrm>
+            <a:off x="749808" y="4965192"/>
+            <a:ext cx="4882896" cy="420624"/>
+          </a:xfrm>
+          <a:prstGeom prst="rect">
+            <a:avLst/>
+          </a:prstGeom>
+          <a:noFill/>
+          <a:ln/>
+        </p:spPr>
+        <p:txBody>
+          <a:bodyPr wrap="square" lIns="0" tIns="0" rIns="0" bIns="0" rtlCol="0" anchor="ctr"/>
+          <a:lstStyle/>
+          <a:p>
+            <a:pPr marL="0" indent="0">
+              <a:lnSpc>
+                <a:spcPct val="130000"/>
+              </a:lnSpc>
+              <a:buNone/>
+            </a:pPr>
+            <a:r>
+              <a:rPr lang="en-US" sz="1050" dirty="0">
+                <a:solidFill>
+                  <a:srgbClr val="45515E"/>
+                </a:solidFill>
+                <a:latin typeface="Pretendard" pitchFamily="34" charset="0"/>
+                <a:ea typeface="Pretendard" pitchFamily="34" charset="-122"/>
+                <a:cs typeface="Pretendard" pitchFamily="34" charset="-120"/>
+              </a:rPr>
+              <a:t>→  src/ 8개 모듈로 분리, python -m src.train --all 한 줄로 전체 재현</a:t>
+            </a:r>
+            <a:endParaRPr lang="en-US" sz="1050" dirty="0"/>
+          </a:p>
+        </p:txBody>
+      </p:sp>
+      <p:sp>
+        <p:nvSpPr>
+          <p:cNvPr id="24" name="Shape 22"/>
+          <p:cNvSpPr/>
+          <p:nvPr/>
+        </p:nvSpPr>
+        <p:spPr>
+          <a:xfrm>
+            <a:off x="6430975" y="2185416"/>
+            <a:ext cx="5394960" cy="3374136"/>
+          </a:xfrm>
+          <a:prstGeom prst="roundRect">
+            <a:avLst>
+              <a:gd name="adj" fmla="val 3523"/>
+            </a:avLst>
+          </a:prstGeom>
+          <a:solidFill>
+            <a:srgbClr val="FFFFFF"/>
+          </a:solidFill>
+          <a:ln w="19050">
+            <a:solidFill>
+              <a:srgbClr val="BBF7D0"/>
+            </a:solidFill>
+            <a:prstDash val="solid"/>
+          </a:ln>
+          <a:effectLst>
+            <a:outerShdw blurRad="101600" dist="50800" dir="8100000" algn="bl" rotWithShape="0">
+              <a:srgbClr val="000000">
+                <a:alpha val="8000"/>
+              </a:srgbClr>
+            </a:outerShdw>
+          </a:effectLst>
+        </p:spPr>
+      </p:sp>
+      <p:sp>
+        <p:nvSpPr>
+          <p:cNvPr id="25" name="Shape 23"/>
+          <p:cNvSpPr/>
+          <p:nvPr/>
+        </p:nvSpPr>
+        <p:spPr>
+          <a:xfrm>
+            <a:off x="6430975" y="2185416"/>
+            <a:ext cx="64008" cy="3374136"/>
+          </a:xfrm>
+          <a:prstGeom prst="rect">
+            <a:avLst/>
+          </a:prstGeom>
+          <a:solidFill>
+            <a:srgbClr val="16A34A"/>
+          </a:solidFill>
+          <a:ln/>
+        </p:spPr>
+      </p:sp>
+      <p:sp>
+        <p:nvSpPr>
+          <p:cNvPr id="26" name="Text 24"/>
+          <p:cNvSpPr/>
+          <p:nvPr/>
+        </p:nvSpPr>
+        <p:spPr>
+          <a:xfrm>
+            <a:off x="6632143" y="2340864"/>
+            <a:ext cx="5074920" cy="274320"/>
+          </a:xfrm>
+          <a:prstGeom prst="rect">
+            <a:avLst/>
+          </a:prstGeom>
+          <a:noFill/>
+          <a:ln/>
+        </p:spPr>
+        <p:txBody>
+          <a:bodyPr wrap="square" lIns="0" tIns="0" rIns="0" bIns="0" rtlCol="0" anchor="ctr"/>
+          <a:lstStyle/>
+          <a:p>
+            <a:pPr marL="0" indent="0">
+              <a:buNone/>
+            </a:pPr>
+            <a:r>
+              <a:rPr lang="en-US" sz="1400" b="1" dirty="0">
+                <a:solidFill>
+                  <a:srgbClr val="16A34A"/>
+                </a:solidFill>
+                <a:latin typeface="Pretendard" pitchFamily="34" charset="0"/>
+                <a:ea typeface="Pretendard" pitchFamily="34" charset="-122"/>
+                <a:cs typeface="Pretendard" pitchFamily="34" charset="-120"/>
+              </a:rPr>
+              <a:t>배운 점</a:t>
+            </a:r>
+            <a:endParaRPr lang="en-US" sz="1400" dirty="0"/>
+          </a:p>
+        </p:txBody>
+      </p:sp>
+      <p:sp>
+        <p:nvSpPr>
+          <p:cNvPr id="27" name="Shape 25"/>
+          <p:cNvSpPr/>
+          <p:nvPr/>
+        </p:nvSpPr>
+        <p:spPr>
+          <a:xfrm>
+            <a:off x="6632143" y="2688336"/>
+            <a:ext cx="4992624" cy="0"/>
+          </a:xfrm>
+          <a:prstGeom prst="line">
+            <a:avLst/>
+          </a:prstGeom>
+          <a:noFill/>
+          <a:ln w="12700">
+            <a:solidFill>
+              <a:srgbClr val="BBF7D0"/>
+            </a:solidFill>
+            <a:prstDash val="solid"/>
+          </a:ln>
+        </p:spPr>
+      </p:sp>
+      <p:sp>
+        <p:nvSpPr>
+          <p:cNvPr id="28" name="Shape 26"/>
+          <p:cNvSpPr/>
+          <p:nvPr/>
+        </p:nvSpPr>
+        <p:spPr>
+          <a:xfrm>
+            <a:off x="6632143" y="2862072"/>
+            <a:ext cx="274320" cy="256032"/>
+          </a:xfrm>
+          <a:prstGeom prst="roundRect">
+            <a:avLst>
+              <a:gd name="adj" fmla="val 17857"/>
+            </a:avLst>
+          </a:prstGeom>
+          <a:solidFill>
+            <a:srgbClr val="F0FDF4"/>
+          </a:solidFill>
+          <a:ln w="12700">
+            <a:solidFill>
+              <a:srgbClr val="BBF7D0"/>
+            </a:solidFill>
+            <a:prstDash val="solid"/>
+          </a:ln>
+        </p:spPr>
+      </p:sp>
+      <p:sp>
+        <p:nvSpPr>
+          <p:cNvPr id="29" name="Text 27"/>
+          <p:cNvSpPr/>
+          <p:nvPr/>
+        </p:nvSpPr>
+        <p:spPr>
+          <a:xfrm>
+            <a:off x="6632143" y="2862072"/>
+            <a:ext cx="274320" cy="256032"/>
+          </a:xfrm>
+          <a:prstGeom prst="rect">
+            <a:avLst/>
+          </a:prstGeom>
+          <a:noFill/>
+          <a:ln/>
+        </p:spPr>
+        <p:txBody>
+          <a:bodyPr wrap="square" lIns="0" tIns="0" rIns="0" bIns="0" rtlCol="0" anchor="ctr"/>
+          <a:lstStyle/>
+          <a:p>
+            <a:pPr marL="0" indent="0" algn="ctr">
+              <a:buNone/>
+            </a:pPr>
+            <a:r>
+              <a:rPr lang="en-US" sz="1000" b="1" dirty="0">
+                <a:solidFill>
+                  <a:srgbClr val="16A34A"/>
+                </a:solidFill>
+                <a:latin typeface="Pretendard" pitchFamily="34" charset="0"/>
+                <a:ea typeface="Pretendard" pitchFamily="34" charset="-122"/>
+                <a:cs typeface="Pretendard" pitchFamily="34" charset="-120"/>
+              </a:rPr>
+              <a:t>01</a:t>
+            </a:r>
+            <a:endParaRPr lang="en-US" sz="1000" dirty="0"/>
+          </a:p>
+        </p:txBody>
+      </p:sp>
+      <p:sp>
+        <p:nvSpPr>
+          <p:cNvPr id="30" name="Text 28"/>
+          <p:cNvSpPr/>
+          <p:nvPr/>
+        </p:nvSpPr>
+        <p:spPr>
+          <a:xfrm>
+            <a:off x="6979615" y="2862072"/>
+            <a:ext cx="4718304" cy="256032"/>
+          </a:xfrm>
+          <a:prstGeom prst="rect">
+            <a:avLst/>
+          </a:prstGeom>
+          <a:noFill/>
+          <a:ln/>
+        </p:spPr>
+        <p:txBody>
+          <a:bodyPr wrap="square" lIns="0" tIns="0" rIns="0" bIns="0" rtlCol="0" anchor="ctr"/>
+          <a:lstStyle/>
+          <a:p>
+            <a:pPr marL="0" indent="0">
+              <a:buNone/>
+            </a:pPr>
+            <a:r>
+              <a:rPr lang="en-US" sz="1200" b="1" dirty="0">
+                <a:solidFill>
+                  <a:srgbClr val="222222"/>
+                </a:solidFill>
+                <a:latin typeface="Pretendard" pitchFamily="34" charset="0"/>
+                <a:ea typeface="Pretendard" pitchFamily="34" charset="-122"/>
+                <a:cs typeface="Pretendard" pitchFamily="34" charset="-120"/>
+              </a:rPr>
+              <a:t>SMOTE가 항상 성능을 높이지 않음</a:t>
+            </a:r>
+            <a:endParaRPr lang="en-US" sz="1200" dirty="0"/>
+          </a:p>
+        </p:txBody>
+      </p:sp>
+      <p:sp>
+        <p:nvSpPr>
+          <p:cNvPr id="31" name="Shape 29"/>
+          <p:cNvSpPr/>
+          <p:nvPr/>
+        </p:nvSpPr>
+        <p:spPr>
+          <a:xfrm>
+            <a:off x="6632143" y="3191256"/>
+            <a:ext cx="4992624" cy="420624"/>
+          </a:xfrm>
+          <a:prstGeom prst="roundRect">
+            <a:avLst>
+              <a:gd name="adj" fmla="val 13043"/>
+            </a:avLst>
+          </a:prstGeom>
+          <a:solidFill>
+            <a:srgbClr val="F0FDF4"/>
+          </a:solidFill>
+          <a:ln w="9525">
+            <a:solidFill>
+              <a:srgbClr val="BBF7D0"/>
+            </a:solidFill>
+            <a:prstDash val="solid"/>
+          </a:ln>
+        </p:spPr>
+      </p:sp>
+      <p:sp>
+        <p:nvSpPr>
+          <p:cNvPr id="32" name="Text 30"/>
+          <p:cNvSpPr/>
+          <p:nvPr/>
+        </p:nvSpPr>
+        <p:spPr>
+          <a:xfrm>
+            <a:off x="6723583" y="3191256"/>
+            <a:ext cx="4882896" cy="420624"/>
+          </a:xfrm>
+          <a:prstGeom prst="rect">
+            <a:avLst/>
+          </a:prstGeom>
+          <a:noFill/>
+          <a:ln/>
+        </p:spPr>
+        <p:txBody>
+          <a:bodyPr wrap="square" lIns="0" tIns="0" rIns="0" bIns="0" rtlCol="0" anchor="ctr"/>
+          <a:lstStyle/>
+          <a:p>
+            <a:pPr marL="0" indent="0">
+              <a:lnSpc>
+                <a:spcPct val="130000"/>
+              </a:lnSpc>
+              <a:buNone/>
+            </a:pPr>
+            <a:r>
+              <a:rPr lang="en-US" sz="1050" dirty="0">
+                <a:solidFill>
+                  <a:srgbClr val="45515E"/>
+                </a:solidFill>
+                <a:latin typeface="Pretendard" pitchFamily="34" charset="0"/>
+                <a:ea typeface="Pretendard" pitchFamily="34" charset="-122"/>
+                <a:cs typeface="Pretendard" pitchFamily="34" charset="-120"/>
+              </a:rPr>
+              <a:t>tree ensemble은 불균형 데이터를 스스로 처리 — SMOTE 적용이 오히려 역효과를 낼 수 있음</a:t>
+            </a:r>
+            <a:endParaRPr lang="en-US" sz="1050" dirty="0"/>
+          </a:p>
+        </p:txBody>
+      </p:sp>
+      <p:sp>
+        <p:nvSpPr>
+          <p:cNvPr id="33" name="Shape 31"/>
+          <p:cNvSpPr/>
+          <p:nvPr/>
+        </p:nvSpPr>
+        <p:spPr>
+          <a:xfrm>
+            <a:off x="6632143" y="3749040"/>
+            <a:ext cx="274320" cy="256032"/>
+          </a:xfrm>
+          <a:prstGeom prst="roundRect">
+            <a:avLst>
+              <a:gd name="adj" fmla="val 17857"/>
+            </a:avLst>
+          </a:prstGeom>
+          <a:solidFill>
+            <a:srgbClr val="F0FDF4"/>
+          </a:solidFill>
+          <a:ln w="12700">
+            <a:solidFill>
+              <a:srgbClr val="BBF7D0"/>
+            </a:solidFill>
+            <a:prstDash val="solid"/>
+          </a:ln>
+        </p:spPr>
+      </p:sp>
+      <p:sp>
+        <p:nvSpPr>
+          <p:cNvPr id="34" name="Text 32"/>
+          <p:cNvSpPr/>
+          <p:nvPr/>
+        </p:nvSpPr>
+        <p:spPr>
+          <a:xfrm>
+            <a:off x="6632143" y="3749040"/>
+            <a:ext cx="274320" cy="256032"/>
+          </a:xfrm>
+          <a:prstGeom prst="rect">
+            <a:avLst/>
+          </a:prstGeom>
+          <a:noFill/>
+          <a:ln/>
+        </p:spPr>
+        <p:txBody>
+          <a:bodyPr wrap="square" lIns="0" tIns="0" rIns="0" bIns="0" rtlCol="0" anchor="ctr"/>
+          <a:lstStyle/>
+          <a:p>
+            <a:pPr marL="0" indent="0" algn="ctr">
+              <a:buNone/>
+            </a:pPr>
+            <a:r>
+              <a:rPr lang="en-US" sz="1000" b="1" dirty="0">
+                <a:solidFill>
+                  <a:srgbClr val="16A34A"/>
+                </a:solidFill>
+                <a:latin typeface="Pretendard" pitchFamily="34" charset="0"/>
+                <a:ea typeface="Pretendard" pitchFamily="34" charset="-122"/>
+                <a:cs typeface="Pretendard" pitchFamily="34" charset="-120"/>
+              </a:rPr>
+              <a:t>02</a:t>
+            </a:r>
+            <a:endParaRPr lang="en-US" sz="1000" dirty="0"/>
+          </a:p>
+        </p:txBody>
+      </p:sp>
+      <p:sp>
+        <p:nvSpPr>
+          <p:cNvPr id="35" name="Text 33"/>
+          <p:cNvSpPr/>
+          <p:nvPr/>
+        </p:nvSpPr>
+        <p:spPr>
+          <a:xfrm>
+            <a:off x="6979615" y="3749040"/>
+            <a:ext cx="4718304" cy="256032"/>
+          </a:xfrm>
+          <a:prstGeom prst="rect">
+            <a:avLst/>
+          </a:prstGeom>
+          <a:noFill/>
+          <a:ln/>
+        </p:spPr>
+        <p:txBody>
+          <a:bodyPr wrap="square" lIns="0" tIns="0" rIns="0" bIns="0" rtlCol="0" anchor="ctr"/>
+          <a:lstStyle/>
+          <a:p>
+            <a:pPr marL="0" indent="0">
+              <a:buNone/>
+            </a:pPr>
+            <a:r>
+              <a:rPr lang="en-US" sz="1200" b="1" dirty="0">
+                <a:solidFill>
+                  <a:srgbClr val="222222"/>
+                </a:solidFill>
+                <a:latin typeface="Pretendard" pitchFamily="34" charset="0"/>
+                <a:ea typeface="Pretendard" pitchFamily="34" charset="-122"/>
+                <a:cs typeface="Pretendard" pitchFamily="34" charset="-120"/>
+              </a:rPr>
+              <a:t>Scaler보다 Encoder 선택이 핵심</a:t>
+            </a:r>
+            <a:endParaRPr lang="en-US" sz="1200" dirty="0"/>
+          </a:p>
+        </p:txBody>
+      </p:sp>
+      <p:sp>
+        <p:nvSpPr>
+          <p:cNvPr id="36" name="Shape 34"/>
+          <p:cNvSpPr/>
+          <p:nvPr/>
+        </p:nvSpPr>
+        <p:spPr>
+          <a:xfrm>
+            <a:off x="6632143" y="4078224"/>
+            <a:ext cx="4992624" cy="420624"/>
+          </a:xfrm>
+          <a:prstGeom prst="roundRect">
+            <a:avLst>
+              <a:gd name="adj" fmla="val 13043"/>
+            </a:avLst>
+          </a:prstGeom>
+          <a:solidFill>
+            <a:srgbClr val="F0FDF4"/>
+          </a:solidFill>
+          <a:ln w="9525">
+            <a:solidFill>
+              <a:srgbClr val="BBF7D0"/>
+            </a:solidFill>
+            <a:prstDash val="solid"/>
+          </a:ln>
+        </p:spPr>
+      </p:sp>
+      <p:sp>
+        <p:nvSpPr>
+          <p:cNvPr id="37" name="Text 35"/>
+          <p:cNvSpPr/>
+          <p:nvPr/>
+        </p:nvSpPr>
+        <p:spPr>
+          <a:xfrm>
+            <a:off x="6723583" y="4078224"/>
+            <a:ext cx="4882896" cy="420624"/>
+          </a:xfrm>
+          <a:prstGeom prst="rect">
+            <a:avLst/>
+          </a:prstGeom>
+          <a:noFill/>
+          <a:ln/>
+        </p:spPr>
+        <p:txBody>
+          <a:bodyPr wrap="square" lIns="0" tIns="0" rIns="0" bIns="0" rtlCol="0" anchor="ctr"/>
+          <a:lstStyle/>
+          <a:p>
+            <a:pPr marL="0" indent="0">
+              <a:lnSpc>
+                <a:spcPct val="130000"/>
+              </a:lnSpc>
+              <a:buNone/>
+            </a:pPr>
+            <a:r>
+              <a:rPr lang="en-US" sz="1050" dirty="0">
+                <a:solidFill>
+                  <a:srgbClr val="45515E"/>
+                </a:solidFill>
+                <a:latin typeface="Pretendard" pitchFamily="34" charset="0"/>
+                <a:ea typeface="Pretendard" pitchFamily="34" charset="-122"/>
+                <a:cs typeface="Pretendard" pitchFamily="34" charset="-120"/>
+              </a:rPr>
+              <a:t>범주형 인코딩 방식이 수치형 스케일링보다 모델 성능에 더 직접적인 영향을 미침</a:t>
+            </a:r>
+            <a:endParaRPr lang="en-US" sz="1050" dirty="0"/>
+          </a:p>
+        </p:txBody>
+      </p:sp>
+      <p:sp>
+        <p:nvSpPr>
+          <p:cNvPr id="38" name="Shape 36"/>
+          <p:cNvSpPr/>
+          <p:nvPr/>
+        </p:nvSpPr>
+        <p:spPr>
+          <a:xfrm>
+            <a:off x="6632143" y="4636008"/>
+            <a:ext cx="274320" cy="256032"/>
+          </a:xfrm>
+          <a:prstGeom prst="roundRect">
+            <a:avLst>
+              <a:gd name="adj" fmla="val 17857"/>
+            </a:avLst>
+          </a:prstGeom>
+          <a:solidFill>
+            <a:srgbClr val="F0FDF4"/>
+          </a:solidFill>
+          <a:ln w="12700">
+            <a:solidFill>
+              <a:srgbClr val="BBF7D0"/>
+            </a:solidFill>
+            <a:prstDash val="solid"/>
+          </a:ln>
+        </p:spPr>
+      </p:sp>
+      <p:sp>
+        <p:nvSpPr>
+          <p:cNvPr id="39" name="Text 37"/>
+          <p:cNvSpPr/>
+          <p:nvPr/>
+        </p:nvSpPr>
+        <p:spPr>
+          <a:xfrm>
+            <a:off x="6632143" y="4636008"/>
+            <a:ext cx="274320" cy="256032"/>
+          </a:xfrm>
+          <a:prstGeom prst="rect">
+            <a:avLst/>
+          </a:prstGeom>
+          <a:noFill/>
+          <a:ln/>
+        </p:spPr>
+        <p:txBody>
+          <a:bodyPr wrap="square" lIns="0" tIns="0" rIns="0" bIns="0" rtlCol="0" anchor="ctr"/>
+          <a:lstStyle/>
+          <a:p>
+            <a:pPr marL="0" indent="0" algn="ctr">
+              <a:buNone/>
+            </a:pPr>
+            <a:r>
+              <a:rPr lang="en-US" sz="1000" b="1" dirty="0">
+                <a:solidFill>
+                  <a:srgbClr val="16A34A"/>
+                </a:solidFill>
+                <a:latin typeface="Pretendard" pitchFamily="34" charset="0"/>
+                <a:ea typeface="Pretendard" pitchFamily="34" charset="-122"/>
+                <a:cs typeface="Pretendard" pitchFamily="34" charset="-120"/>
+              </a:rPr>
+              <a:t>03</a:t>
+            </a:r>
+            <a:endParaRPr lang="en-US" sz="1000" dirty="0"/>
+          </a:p>
+        </p:txBody>
+      </p:sp>
+      <p:sp>
+        <p:nvSpPr>
+          <p:cNvPr id="40" name="Text 38"/>
+          <p:cNvSpPr/>
+          <p:nvPr/>
+        </p:nvSpPr>
+        <p:spPr>
+          <a:xfrm>
+            <a:off x="6979615" y="4636008"/>
+            <a:ext cx="4718304" cy="256032"/>
+          </a:xfrm>
+          <a:prstGeom prst="rect">
+            <a:avLst/>
+          </a:prstGeom>
+          <a:noFill/>
+          <a:ln/>
+        </p:spPr>
+        <p:txBody>
+          <a:bodyPr wrap="square" lIns="0" tIns="0" rIns="0" bIns="0" rtlCol="0" anchor="ctr"/>
+          <a:lstStyle/>
+          <a:p>
+            <a:pPr marL="0" indent="0">
+              <a:buNone/>
+            </a:pPr>
+            <a:r>
+              <a:rPr lang="en-US" sz="1200" b="1" dirty="0">
+                <a:solidFill>
+                  <a:srgbClr val="222222"/>
+                </a:solidFill>
+                <a:latin typeface="Pretendard" pitchFamily="34" charset="0"/>
+                <a:ea typeface="Pretendard" pitchFamily="34" charset="-122"/>
+                <a:cs typeface="Pretendard" pitchFamily="34" charset="-120"/>
+              </a:rPr>
+              <a:t>실험 결과 자동 저장으로 효율화</a:t>
+            </a:r>
+            <a:endParaRPr lang="en-US" sz="1200" dirty="0"/>
+          </a:p>
+        </p:txBody>
+      </p:sp>
+      <p:sp>
+        <p:nvSpPr>
+          <p:cNvPr id="41" name="Shape 39"/>
+          <p:cNvSpPr/>
+          <p:nvPr/>
+        </p:nvSpPr>
+        <p:spPr>
+          <a:xfrm>
+            <a:off x="6632143" y="4965192"/>
+            <a:ext cx="4992624" cy="420624"/>
+          </a:xfrm>
+          <a:prstGeom prst="roundRect">
+            <a:avLst>
+              <a:gd name="adj" fmla="val 13043"/>
+            </a:avLst>
+          </a:prstGeom>
+          <a:solidFill>
+            <a:srgbClr val="F0FDF4"/>
+          </a:solidFill>
+          <a:ln w="9525">
+            <a:solidFill>
+              <a:srgbClr val="BBF7D0"/>
+            </a:solidFill>
+            <a:prstDash val="solid"/>
+          </a:ln>
+        </p:spPr>
+      </p:sp>
+      <p:sp>
+        <p:nvSpPr>
+          <p:cNvPr id="42" name="Text 40"/>
+          <p:cNvSpPr/>
+          <p:nvPr/>
+        </p:nvSpPr>
+        <p:spPr>
+          <a:xfrm>
+            <a:off x="6723583" y="4965192"/>
+            <a:ext cx="4882896" cy="420624"/>
+          </a:xfrm>
+          <a:prstGeom prst="rect">
+            <a:avLst/>
+          </a:prstGeom>
+          <a:noFill/>
+          <a:ln/>
+        </p:spPr>
+        <p:txBody>
+          <a:bodyPr wrap="square" lIns="0" tIns="0" rIns="0" bIns="0" rtlCol="0" anchor="ctr"/>
+          <a:lstStyle/>
+          <a:p>
+            <a:pPr marL="0" indent="0">
+              <a:lnSpc>
+                <a:spcPct val="130000"/>
+              </a:lnSpc>
+              <a:buNone/>
+            </a:pPr>
+            <a:r>
+              <a:rPr lang="en-US" sz="1050" dirty="0">
+                <a:solidFill>
+                  <a:srgbClr val="45515E"/>
+                </a:solidFill>
+                <a:latin typeface="Pretendard" pitchFamily="34" charset="0"/>
+                <a:ea typeface="Pretendard" pitchFamily="34" charset="-122"/>
+                <a:cs typeface="Pretendard" pitchFamily="34" charset="-120"/>
+              </a:rPr>
+              <a:t>모든 실험 결과를 자동 저장해 보고서 작성 시간 단축 및 재현성 확보</a:t>
+            </a:r>
+            <a:endParaRPr lang="en-US" sz="1050" dirty="0"/>
+          </a:p>
+        </p:txBody>
+      </p:sp>
+      <p:sp>
+        <p:nvSpPr>
+          <p:cNvPr id="43" name="Text 41"/>
+          <p:cNvSpPr/>
+          <p:nvPr/>
+        </p:nvSpPr>
+        <p:spPr>
+          <a:xfrm>
+            <a:off x="457200" y="6446520"/>
+            <a:ext cx="914400" cy="228600"/>
+          </a:xfrm>
+          <a:prstGeom prst="rect">
+            <a:avLst/>
+          </a:prstGeom>
+          <a:noFill/>
+          <a:ln/>
+        </p:spPr>
+        <p:txBody>
+          <a:bodyPr wrap="square" lIns="0" tIns="0" rIns="0" bIns="0" rtlCol="0" anchor="ctr"/>
+          <a:lstStyle/>
+          <a:p>
+            <a:pPr marL="0" indent="0">
+              <a:buNone/>
+            </a:pPr>
+            <a:r>
+              <a:rPr lang="en-US" sz="1000" dirty="0">
+                <a:solidFill>
+                  <a:srgbClr val="8E8E93"/>
+                </a:solidFill>
+                <a:latin typeface="Pretendard" pitchFamily="34" charset="0"/>
+                <a:ea typeface="Pretendard" pitchFamily="34" charset="-122"/>
+                <a:cs typeface="Pretendard" pitchFamily="34" charset="-120"/>
+              </a:rPr>
+              <a:t>8</a:t>
+            </a:r>
+            <a:endParaRPr lang="en-US" sz="1000" dirty="0"/>
+          </a:p>
+        </p:txBody>
+      </p:sp>
+      <p:sp>
+        <p:nvSpPr>
+          <p:cNvPr id="44" name="Text 42"/>
+          <p:cNvSpPr/>
+          <p:nvPr/>
+        </p:nvSpPr>
+        <p:spPr>
+          <a:xfrm>
+            <a:off x="-243688" y="6377940"/>
+            <a:ext cx="12191695" cy="228600"/>
+          </a:xfrm>
+          <a:prstGeom prst="rect">
+            <a:avLst/>
+          </a:prstGeom>
+          <a:noFill/>
+          <a:ln/>
+        </p:spPr>
+        <p:txBody>
+          <a:bodyPr wrap="square" lIns="0" tIns="0" rIns="6350" bIns="0" rtlCol="0" anchor="ctr"/>
+          <a:lstStyle/>
+          <a:p>
+            <a:pPr marL="0" indent="0" algn="r">
+              <a:buNone/>
+            </a:pPr>
+            <a:r>
+              <a:rPr lang="en-US" sz="900" dirty="0">
+                <a:solidFill>
+                  <a:srgbClr val="8E8E93"/>
+                </a:solidFill>
+                <a:latin typeface="Pretendard" pitchFamily="34" charset="0"/>
+                <a:ea typeface="Pretendard" pitchFamily="34" charset="-122"/>
+                <a:cs typeface="Pretendard" pitchFamily="34" charset="-120"/>
+              </a:rPr>
+              <a:t>Team 6 Data Science Term Project</a:t>
+            </a:r>
+            <a:endParaRPr lang="en-US" sz="900" dirty="0"/>
+          </a:p>
+        </p:txBody>
+      </p:sp>
+      <p:sp>
+        <p:nvSpPr>
+          <p:cNvPr id="45" name="TopBar">
+            <a:extLst>
+              <a:ext uri="{FF2B5EF4-FFF2-40B4-BE49-F238E27FC236}">
+                <a16:creationId xmlns:a16="http://schemas.microsoft.com/office/drawing/2014/main" id="{A0237DE9-9CC7-474F-BCBE-219382570CEE}"/>
+              </a:ext>
+            </a:extLst>
+          </p:cNvPr>
+          <p:cNvSpPr/>
+          <p:nvPr/>
+        </p:nvSpPr>
+        <p:spPr>
+          <a:xfrm>
+            <a:off x="0" y="0"/>
+            <a:ext cx="12191695" cy="128016"/>
+          </a:xfrm>
+          <a:prstGeom prst="rect">
+            <a:avLst/>
+          </a:prstGeom>
+          <a:solidFill>
+            <a:srgbClr val="0F766E"/>
+          </a:solidFill>
+          <a:ln w="12700">
+            <a:solidFill>
+              <a:srgbClr val="0F766E"/>
+            </a:solidFill>
+            <a:prstDash val="solid"/>
+          </a:ln>
+        </p:spPr>
+        <p:txBody>
+          <a:bodyPr/>
+          <a:lstStyle/>
+          <a:p>
+            <a:endParaRPr lang="ko-KR" altLang="en-US"/>
+          </a:p>
+        </p:txBody>
+      </p:sp>
+    </p:spTree>
+  </p:cSld>
+  <p:clrMapOvr>
+    <a:masterClrMapping/>
+  </p:clrMapOvr>
+</p:sld>
+</file>
+
+<file path=ppt/slides/slide19.xml><?xml version="1.0" encoding="utf-8"?>
+<p:sld xmlns:a="http://schemas.openxmlformats.org/drawingml/2006/main" xmlns:r="http://schemas.openxmlformats.org/officeDocument/2006/relationships" xmlns:p="http://schemas.openxmlformats.org/presentationml/2006/main">
+  <p:cSld>
+    <p:spTree>
+      <p:nvGrpSpPr>
+        <p:cNvPr id="1" name=""/>
+        <p:cNvGrpSpPr/>
+        <p:nvPr/>
+      </p:nvGrpSpPr>
+      <p:grpSpPr>
+        <a:xfrm>
+          <a:off x="0" y="0"/>
+          <a:ext cx="0" cy="0"/>
+          <a:chOff x="0" y="0"/>
+          <a:chExt cx="0" cy="0"/>
+        </a:xfrm>
+      </p:grpSpPr>
+      <p:sp>
+        <p:nvSpPr>
+          <p:cNvPr id="2" name="Text 0"/>
+          <p:cNvSpPr/>
+          <p:nvPr/>
+        </p:nvSpPr>
+        <p:spPr>
+          <a:xfrm>
+            <a:off x="457200" y="365760"/>
+            <a:ext cx="7315200" cy="274320"/>
+          </a:xfrm>
+          <a:prstGeom prst="rect">
+            <a:avLst/>
+          </a:prstGeom>
+          <a:noFill/>
+          <a:ln/>
+        </p:spPr>
+        <p:txBody>
+          <a:bodyPr wrap="square" lIns="0" tIns="0" rIns="0" bIns="0" rtlCol="0" anchor="ctr"/>
+          <a:lstStyle/>
+          <a:p>
+            <a:pPr marL="0" indent="0">
+              <a:buNone/>
+            </a:pPr>
+            <a:r>
+              <a:rPr lang="en-US" sz="1200" dirty="0">
+                <a:solidFill>
+                  <a:srgbClr val="8E8E93"/>
+                </a:solidFill>
+                <a:latin typeface="Pretendard" pitchFamily="34" charset="0"/>
+                <a:ea typeface="Pretendard" pitchFamily="34" charset="-122"/>
+                <a:cs typeface="Pretendard" pitchFamily="34" charset="-120"/>
+              </a:rPr>
+              <a:t>08 Learning Experience</a:t>
+            </a:r>
+            <a:endParaRPr lang="en-US" sz="1200" dirty="0"/>
+          </a:p>
+        </p:txBody>
+      </p:sp>
+      <p:sp>
+        <p:nvSpPr>
+          <p:cNvPr id="3" name="Text 1"/>
+          <p:cNvSpPr/>
+          <p:nvPr/>
+        </p:nvSpPr>
+        <p:spPr>
+          <a:xfrm>
+            <a:off x="457199" y="571500"/>
+            <a:ext cx="11277295" cy="685800"/>
+          </a:xfrm>
+          <a:prstGeom prst="rect">
+            <a:avLst/>
+          </a:prstGeom>
+          <a:noFill/>
+          <a:ln/>
+        </p:spPr>
+        <p:txBody>
+          <a:bodyPr wrap="square" lIns="0" tIns="0" rIns="0" bIns="0" rtlCol="0" anchor="ctr"/>
+          <a:lstStyle/>
+          <a:p>
+            <a:pPr marL="0" indent="0">
+              <a:lnSpc>
+                <a:spcPct val="120000"/>
+              </a:lnSpc>
+              <a:buNone/>
+            </a:pPr>
+            <a:r>
+              <a:rPr lang="en-US" sz="3600" b="1" dirty="0">
+                <a:solidFill>
+                  <a:srgbClr val="222222"/>
+                </a:solidFill>
+                <a:latin typeface="Pretendard" pitchFamily="34" charset="0"/>
+                <a:ea typeface="Pretendard" pitchFamily="34" charset="-122"/>
+                <a:cs typeface="Pretendard" pitchFamily="34" charset="-120"/>
+              </a:rPr>
+              <a:t>Open Source SW</a:t>
+            </a:r>
+            <a:endParaRPr lang="en-US" sz="3600" dirty="0"/>
+          </a:p>
+        </p:txBody>
+      </p:sp>
+      <p:sp>
+        <p:nvSpPr>
+          <p:cNvPr id="4" name="Text 2"/>
+          <p:cNvSpPr/>
+          <p:nvPr/>
+        </p:nvSpPr>
+        <p:spPr>
+          <a:xfrm>
+            <a:off x="457198" y="1190140"/>
+            <a:ext cx="11277295" cy="365760"/>
+          </a:xfrm>
+          <a:prstGeom prst="rect">
+            <a:avLst/>
+          </a:prstGeom>
+          <a:noFill/>
+          <a:ln/>
+        </p:spPr>
+        <p:txBody>
+          <a:bodyPr wrap="square" lIns="0" tIns="0" rIns="0" bIns="0" rtlCol="0" anchor="ctr"/>
+          <a:lstStyle/>
+          <a:p>
+            <a:pPr marL="0" indent="0">
+              <a:lnSpc>
+                <a:spcPct val="145000"/>
+              </a:lnSpc>
+              <a:buNone/>
+            </a:pPr>
+            <a:r>
+              <a:rPr lang="en-US" sz="1600" dirty="0">
+                <a:solidFill>
+                  <a:srgbClr val="45515E"/>
+                </a:solidFill>
+                <a:latin typeface="Pretendard" pitchFamily="34" charset="0"/>
+                <a:ea typeface="Pretendard" pitchFamily="34" charset="-122"/>
+                <a:cs typeface="Pretendard" pitchFamily="34" charset="-120"/>
+              </a:rPr>
+              <a:t>프로젝트 소스코드를 GitHub에 공개하였으며, src/ 모듈 구조로 재현성을 확보했습니다</a:t>
+            </a:r>
+            <a:endParaRPr lang="en-US" sz="1600" dirty="0"/>
+          </a:p>
+        </p:txBody>
+      </p:sp>
+      <p:grpSp>
+        <p:nvGrpSpPr>
+          <p:cNvPr id="35" name="그룹 34">
+            <a:extLst>
+              <a:ext uri="{FF2B5EF4-FFF2-40B4-BE49-F238E27FC236}">
+                <a16:creationId xmlns:a16="http://schemas.microsoft.com/office/drawing/2014/main" id="{788A1B6F-619B-4160-A77D-2B6320005F7A}"/>
+              </a:ext>
+            </a:extLst>
+          </p:cNvPr>
+          <p:cNvGrpSpPr/>
+          <p:nvPr/>
+        </p:nvGrpSpPr>
+        <p:grpSpPr>
+          <a:xfrm>
+            <a:off x="457197" y="1703802"/>
+            <a:ext cx="11277295" cy="585216"/>
+            <a:chOff x="512064" y="2185416"/>
+            <a:chExt cx="11277295" cy="585216"/>
+          </a:xfrm>
+        </p:grpSpPr>
+        <p:sp>
+          <p:nvSpPr>
+            <p:cNvPr id="5" name="Shape 3"/>
+            <p:cNvSpPr/>
+            <p:nvPr/>
+          </p:nvSpPr>
+          <p:spPr>
+            <a:xfrm>
+              <a:off x="512064" y="2185416"/>
+              <a:ext cx="11277295" cy="585216"/>
+            </a:xfrm>
+            <a:prstGeom prst="roundRect">
+              <a:avLst>
+                <a:gd name="adj" fmla="val 15625"/>
+              </a:avLst>
+            </a:prstGeom>
+            <a:solidFill>
+              <a:srgbClr val="181E25"/>
+            </a:solidFill>
+            <a:ln/>
+            <a:effectLst>
+              <a:outerShdw blurRad="190500" dist="50800" dir="8100000" algn="bl" rotWithShape="0">
+                <a:srgbClr val="2C1E74">
+                  <a:alpha val="16000"/>
+                </a:srgbClr>
+              </a:outerShdw>
+            </a:effectLst>
+          </p:spPr>
+        </p:sp>
+        <p:sp>
+          <p:nvSpPr>
+            <p:cNvPr id="6" name="Text 4"/>
+            <p:cNvSpPr/>
+            <p:nvPr/>
+          </p:nvSpPr>
+          <p:spPr>
+            <a:xfrm>
+              <a:off x="731520" y="2185416"/>
+              <a:ext cx="10728655" cy="585216"/>
+            </a:xfrm>
+            <a:prstGeom prst="rect">
+              <a:avLst/>
+            </a:prstGeom>
+            <a:noFill/>
+            <a:ln/>
+          </p:spPr>
+          <p:txBody>
+            <a:bodyPr wrap="square" lIns="0" tIns="0" rIns="0" bIns="0" rtlCol="0" anchor="ctr"/>
+            <a:lstStyle/>
+            <a:p>
+              <a:pPr marL="0" indent="0" algn="ctr">
+                <a:buNone/>
+              </a:pPr>
+              <a:r>
+                <a:rPr lang="en-US" sz="1400" b="1" dirty="0">
+                  <a:solidFill>
+                    <a:srgbClr val="8E8E93"/>
+                  </a:solidFill>
+                  <a:latin typeface="Pretendard" pitchFamily="34" charset="0"/>
+                  <a:ea typeface="Pretendard" pitchFamily="34" charset="-122"/>
+                  <a:cs typeface="Pretendard" pitchFamily="34" charset="-120"/>
+                </a:rPr>
+                <a:t>오픈소스 공개  </a:t>
+              </a:r>
+              <a:r>
+                <a:rPr lang="en-US" sz="1400" dirty="0">
+                  <a:solidFill>
+                    <a:srgbClr val="FFFFFF"/>
+                  </a:solidFill>
+                  <a:latin typeface="Pretendard" pitchFamily="34" charset="0"/>
+                  <a:ea typeface="Pretendard" pitchFamily="34" charset="-122"/>
+                  <a:cs typeface="Pretendard" pitchFamily="34" charset="-120"/>
+                </a:rPr>
+                <a:t>github.com/Hanharam/DS-credit-score-project</a:t>
+              </a:r>
+              <a:endParaRPr lang="en-US" sz="1400" dirty="0"/>
+            </a:p>
+          </p:txBody>
+        </p:sp>
+      </p:grpSp>
+      <p:grpSp>
+        <p:nvGrpSpPr>
+          <p:cNvPr id="36" name="그룹 35">
+            <a:extLst>
+              <a:ext uri="{FF2B5EF4-FFF2-40B4-BE49-F238E27FC236}">
+                <a16:creationId xmlns:a16="http://schemas.microsoft.com/office/drawing/2014/main" id="{59AFAAE1-24C2-4B93-BD14-1B6945AB4C74}"/>
+              </a:ext>
+            </a:extLst>
+          </p:cNvPr>
+          <p:cNvGrpSpPr/>
+          <p:nvPr/>
+        </p:nvGrpSpPr>
+        <p:grpSpPr>
+          <a:xfrm>
+            <a:off x="457200" y="2516109"/>
+            <a:ext cx="11277295" cy="3703320"/>
+            <a:chOff x="457200" y="2971800"/>
+            <a:chExt cx="11277295" cy="3703320"/>
+          </a:xfrm>
+        </p:grpSpPr>
+        <p:sp>
+          <p:nvSpPr>
+            <p:cNvPr id="7" name="Text 5"/>
+            <p:cNvSpPr/>
+            <p:nvPr/>
+          </p:nvSpPr>
+          <p:spPr>
+            <a:xfrm>
+              <a:off x="457200" y="2971800"/>
+              <a:ext cx="11277295" cy="292608"/>
+            </a:xfrm>
+            <a:prstGeom prst="rect">
+              <a:avLst/>
+            </a:prstGeom>
+            <a:noFill/>
+            <a:ln/>
+          </p:spPr>
+          <p:txBody>
+            <a:bodyPr wrap="square" lIns="0" tIns="0" rIns="0" bIns="0" rtlCol="0" anchor="ctr"/>
+            <a:lstStyle/>
+            <a:p>
+              <a:pPr marL="0" indent="0">
+                <a:buNone/>
+              </a:pPr>
+              <a:r>
+                <a:rPr lang="en-US" sz="1400" b="1" dirty="0">
+                  <a:solidFill>
+                    <a:srgbClr val="222222"/>
+                  </a:solidFill>
+                  <a:latin typeface="Pretendard" pitchFamily="34" charset="0"/>
+                  <a:ea typeface="Pretendard" pitchFamily="34" charset="-122"/>
+                  <a:cs typeface="Pretendard" pitchFamily="34" charset="-120"/>
+                </a:rPr>
+                <a:t>src/  모듈 구조</a:t>
+              </a:r>
+              <a:endParaRPr lang="en-US" sz="1400" dirty="0"/>
+            </a:p>
+          </p:txBody>
+        </p:sp>
+        <p:sp>
+          <p:nvSpPr>
+            <p:cNvPr id="8" name="Shape 6"/>
+            <p:cNvSpPr/>
+            <p:nvPr/>
+          </p:nvSpPr>
+          <p:spPr>
+            <a:xfrm>
+              <a:off x="457200" y="3337560"/>
+              <a:ext cx="11277295" cy="548640"/>
+            </a:xfrm>
+            <a:prstGeom prst="roundRect">
+              <a:avLst>
+                <a:gd name="adj" fmla="val 15000"/>
+              </a:avLst>
+            </a:prstGeom>
+            <a:solidFill>
+              <a:srgbClr val="FFFFFF"/>
+            </a:solidFill>
+            <a:ln w="12700">
+              <a:solidFill>
+                <a:srgbClr val="E5E7EB"/>
+              </a:solidFill>
+              <a:prstDash val="solid"/>
+            </a:ln>
+            <a:effectLst>
+              <a:outerShdw blurRad="101600" dist="50800" dir="8100000" algn="bl" rotWithShape="0">
+                <a:srgbClr val="000000">
+                  <a:alpha val="8000"/>
+                </a:srgbClr>
+              </a:outerShdw>
+            </a:effectLst>
+          </p:spPr>
+        </p:sp>
+        <p:sp>
+          <p:nvSpPr>
+            <p:cNvPr id="9" name="Shape 7"/>
+            <p:cNvSpPr/>
+            <p:nvPr/>
+          </p:nvSpPr>
+          <p:spPr>
+            <a:xfrm>
+              <a:off x="457200" y="3337560"/>
+              <a:ext cx="54864" cy="548640"/>
+            </a:xfrm>
+            <a:prstGeom prst="rect">
+              <a:avLst/>
+            </a:prstGeom>
+            <a:solidFill>
+              <a:srgbClr val="3B82F6"/>
+            </a:solidFill>
+            <a:ln/>
+          </p:spPr>
+        </p:sp>
+        <p:sp>
+          <p:nvSpPr>
+            <p:cNvPr id="10" name="Shape 8"/>
+            <p:cNvSpPr/>
+            <p:nvPr/>
+          </p:nvSpPr>
+          <p:spPr>
+            <a:xfrm>
+              <a:off x="640080" y="3493008"/>
+              <a:ext cx="2926080" cy="292608"/>
+            </a:xfrm>
+            <a:prstGeom prst="roundRect">
+              <a:avLst>
+                <a:gd name="adj" fmla="val 21875"/>
+              </a:avLst>
+            </a:prstGeom>
+            <a:solidFill>
+              <a:srgbClr val="EFF6FF"/>
+            </a:solidFill>
+            <a:ln w="12700">
+              <a:solidFill>
+                <a:srgbClr val="BFDBFE"/>
+              </a:solidFill>
+              <a:prstDash val="solid"/>
+            </a:ln>
+          </p:spPr>
+        </p:sp>
+        <p:sp>
+          <p:nvSpPr>
+            <p:cNvPr id="11" name="Text 9"/>
+            <p:cNvSpPr/>
+            <p:nvPr/>
+          </p:nvSpPr>
+          <p:spPr>
+            <a:xfrm>
+              <a:off x="676656" y="3493008"/>
+              <a:ext cx="2852928" cy="292608"/>
+            </a:xfrm>
+            <a:prstGeom prst="rect">
+              <a:avLst/>
+            </a:prstGeom>
+            <a:noFill/>
+            <a:ln/>
+          </p:spPr>
+          <p:txBody>
+            <a:bodyPr wrap="square" lIns="0" tIns="0" rIns="0" bIns="0" rtlCol="0" anchor="ctr"/>
+            <a:lstStyle/>
+            <a:p>
+              <a:pPr marL="0" indent="0">
+                <a:buNone/>
+              </a:pPr>
+              <a:r>
+                <a:rPr lang="en-US" sz="1100" b="1" dirty="0">
+                  <a:solidFill>
+                    <a:srgbClr val="1456F0"/>
+                  </a:solidFill>
+                  <a:latin typeface="Pretendard" pitchFamily="34" charset="0"/>
+                  <a:ea typeface="Pretendard" pitchFamily="34" charset="-122"/>
+                  <a:cs typeface="Pretendard" pitchFamily="34" charset="-120"/>
+                </a:rPr>
+                <a:t>preprocessing.py</a:t>
+              </a:r>
+              <a:endParaRPr lang="en-US" sz="1100" dirty="0"/>
+            </a:p>
+          </p:txBody>
+        </p:sp>
+        <p:sp>
+          <p:nvSpPr>
+            <p:cNvPr id="12" name="Text 10"/>
+            <p:cNvSpPr/>
+            <p:nvPr/>
+          </p:nvSpPr>
+          <p:spPr>
+            <a:xfrm>
+              <a:off x="3730752" y="3337560"/>
+              <a:ext cx="7820863" cy="548640"/>
+            </a:xfrm>
+            <a:prstGeom prst="rect">
+              <a:avLst/>
+            </a:prstGeom>
+            <a:noFill/>
+            <a:ln/>
+          </p:spPr>
+          <p:txBody>
+            <a:bodyPr wrap="square" lIns="0" tIns="0" rIns="0" bIns="0" rtlCol="0" anchor="ctr"/>
+            <a:lstStyle/>
+            <a:p>
+              <a:pPr marL="0" indent="0">
+                <a:buNone/>
+              </a:pPr>
+              <a:r>
+                <a:rPr lang="en-US" sz="1200" dirty="0">
+                  <a:solidFill>
+                    <a:srgbClr val="45515E"/>
+                  </a:solidFill>
+                  <a:latin typeface="Pretendard" pitchFamily="34" charset="0"/>
+                  <a:ea typeface="Pretendard" pitchFamily="34" charset="-122"/>
+                  <a:cs typeface="Pretendard" pitchFamily="34" charset="-120"/>
+                </a:rPr>
+                <a:t>— 세척, imputation, feature engineering</a:t>
+              </a:r>
+              <a:endParaRPr lang="en-US" sz="1200" dirty="0"/>
+            </a:p>
+          </p:txBody>
+        </p:sp>
+        <p:sp>
+          <p:nvSpPr>
+            <p:cNvPr id="13" name="Shape 11"/>
+            <p:cNvSpPr/>
+            <p:nvPr/>
+          </p:nvSpPr>
+          <p:spPr>
+            <a:xfrm>
+              <a:off x="457200" y="3986784"/>
+              <a:ext cx="11277295" cy="548640"/>
+            </a:xfrm>
+            <a:prstGeom prst="roundRect">
+              <a:avLst>
+                <a:gd name="adj" fmla="val 15000"/>
+              </a:avLst>
+            </a:prstGeom>
+            <a:solidFill>
+              <a:srgbClr val="FFFFFF"/>
+            </a:solidFill>
+            <a:ln w="12700">
+              <a:solidFill>
+                <a:srgbClr val="E5E7EB"/>
+              </a:solidFill>
+              <a:prstDash val="solid"/>
+            </a:ln>
+            <a:effectLst>
+              <a:outerShdw blurRad="101600" dist="50800" dir="8100000" algn="bl" rotWithShape="0">
+                <a:srgbClr val="000000">
+                  <a:alpha val="8000"/>
+                </a:srgbClr>
+              </a:outerShdw>
+            </a:effectLst>
+          </p:spPr>
+        </p:sp>
+        <p:sp>
+          <p:nvSpPr>
+            <p:cNvPr id="14" name="Shape 12"/>
+            <p:cNvSpPr/>
+            <p:nvPr/>
+          </p:nvSpPr>
+          <p:spPr>
+            <a:xfrm>
+              <a:off x="457200" y="3986784"/>
+              <a:ext cx="54864" cy="548640"/>
+            </a:xfrm>
+            <a:prstGeom prst="rect">
+              <a:avLst/>
+            </a:prstGeom>
+            <a:solidFill>
+              <a:srgbClr val="3B82F6"/>
+            </a:solidFill>
+            <a:ln/>
+          </p:spPr>
+        </p:sp>
+        <p:sp>
+          <p:nvSpPr>
+            <p:cNvPr id="15" name="Shape 13"/>
+            <p:cNvSpPr/>
+            <p:nvPr/>
+          </p:nvSpPr>
+          <p:spPr>
+            <a:xfrm>
+              <a:off x="640080" y="4142232"/>
+              <a:ext cx="2926080" cy="292608"/>
+            </a:xfrm>
+            <a:prstGeom prst="roundRect">
+              <a:avLst>
+                <a:gd name="adj" fmla="val 21875"/>
+              </a:avLst>
+            </a:prstGeom>
+            <a:solidFill>
+              <a:srgbClr val="EFF6FF"/>
+            </a:solidFill>
+            <a:ln w="12700">
+              <a:solidFill>
+                <a:srgbClr val="BFDBFE"/>
+              </a:solidFill>
+              <a:prstDash val="solid"/>
+            </a:ln>
+          </p:spPr>
+        </p:sp>
+        <p:sp>
+          <p:nvSpPr>
+            <p:cNvPr id="16" name="Text 14"/>
+            <p:cNvSpPr/>
+            <p:nvPr/>
+          </p:nvSpPr>
+          <p:spPr>
+            <a:xfrm>
+              <a:off x="676656" y="4142232"/>
+              <a:ext cx="2852928" cy="292608"/>
+            </a:xfrm>
+            <a:prstGeom prst="rect">
+              <a:avLst/>
+            </a:prstGeom>
+            <a:noFill/>
+            <a:ln/>
+          </p:spPr>
+          <p:txBody>
+            <a:bodyPr wrap="square" lIns="0" tIns="0" rIns="0" bIns="0" rtlCol="0" anchor="ctr"/>
+            <a:lstStyle/>
+            <a:p>
+              <a:pPr marL="0" indent="0">
+                <a:buNone/>
+              </a:pPr>
+              <a:r>
+                <a:rPr lang="en-US" sz="1100" b="1" dirty="0">
+                  <a:solidFill>
+                    <a:srgbClr val="1456F0"/>
+                  </a:solidFill>
+                  <a:latin typeface="Pretendard" pitchFamily="34" charset="0"/>
+                  <a:ea typeface="Pretendard" pitchFamily="34" charset="-122"/>
+                  <a:cs typeface="Pretendard" pitchFamily="34" charset="-120"/>
+                </a:rPr>
+                <a:t>model.py</a:t>
+              </a:r>
+              <a:endParaRPr lang="en-US" sz="1100" dirty="0"/>
+            </a:p>
+          </p:txBody>
+        </p:sp>
+        <p:sp>
+          <p:nvSpPr>
+            <p:cNvPr id="17" name="Text 15"/>
+            <p:cNvSpPr/>
+            <p:nvPr/>
+          </p:nvSpPr>
+          <p:spPr>
+            <a:xfrm>
+              <a:off x="3730752" y="3986784"/>
+              <a:ext cx="7820863" cy="548640"/>
+            </a:xfrm>
+            <a:prstGeom prst="rect">
+              <a:avLst/>
+            </a:prstGeom>
+            <a:noFill/>
+            <a:ln/>
+          </p:spPr>
+          <p:txBody>
+            <a:bodyPr wrap="square" lIns="0" tIns="0" rIns="0" bIns="0" rtlCol="0" anchor="ctr"/>
+            <a:lstStyle/>
+            <a:p>
+              <a:pPr marL="0" indent="0">
+                <a:buNone/>
+              </a:pPr>
+              <a:r>
+                <a:rPr lang="en-US" sz="1200" dirty="0">
+                  <a:solidFill>
+                    <a:srgbClr val="45515E"/>
+                  </a:solidFill>
+                  <a:latin typeface="Pretendard" pitchFamily="34" charset="0"/>
+                  <a:ea typeface="Pretendard" pitchFamily="34" charset="-122"/>
+                  <a:cs typeface="Pretendard" pitchFamily="34" charset="-120"/>
+                </a:rPr>
+                <a:t>— 모델 정의 및 파라미터 그리드</a:t>
+              </a:r>
+              <a:endParaRPr lang="en-US" sz="1200" dirty="0"/>
+            </a:p>
+          </p:txBody>
+        </p:sp>
+        <p:sp>
+          <p:nvSpPr>
+            <p:cNvPr id="18" name="Shape 16"/>
+            <p:cNvSpPr/>
+            <p:nvPr/>
+          </p:nvSpPr>
+          <p:spPr>
+            <a:xfrm>
+              <a:off x="457200" y="4636008"/>
+              <a:ext cx="11277295" cy="548640"/>
+            </a:xfrm>
+            <a:prstGeom prst="roundRect">
+              <a:avLst>
+                <a:gd name="adj" fmla="val 15000"/>
+              </a:avLst>
+            </a:prstGeom>
+            <a:solidFill>
+              <a:srgbClr val="FFFFFF"/>
+            </a:solidFill>
+            <a:ln w="12700">
+              <a:solidFill>
+                <a:srgbClr val="E5E7EB"/>
+              </a:solidFill>
+              <a:prstDash val="solid"/>
+            </a:ln>
+            <a:effectLst>
+              <a:outerShdw blurRad="101600" dist="50800" dir="8100000" algn="bl" rotWithShape="0">
+                <a:srgbClr val="000000">
+                  <a:alpha val="8000"/>
+                </a:srgbClr>
+              </a:outerShdw>
+            </a:effectLst>
+          </p:spPr>
+        </p:sp>
+        <p:sp>
+          <p:nvSpPr>
+            <p:cNvPr id="19" name="Shape 17"/>
+            <p:cNvSpPr/>
+            <p:nvPr/>
+          </p:nvSpPr>
+          <p:spPr>
+            <a:xfrm>
+              <a:off x="457200" y="4636008"/>
+              <a:ext cx="54864" cy="548640"/>
+            </a:xfrm>
+            <a:prstGeom prst="rect">
+              <a:avLst/>
+            </a:prstGeom>
+            <a:solidFill>
+              <a:srgbClr val="3B82F6"/>
+            </a:solidFill>
+            <a:ln/>
+          </p:spPr>
+        </p:sp>
+        <p:sp>
+          <p:nvSpPr>
+            <p:cNvPr id="20" name="Shape 18"/>
+            <p:cNvSpPr/>
+            <p:nvPr/>
+          </p:nvSpPr>
+          <p:spPr>
+            <a:xfrm>
+              <a:off x="640080" y="4791456"/>
+              <a:ext cx="2926080" cy="292608"/>
+            </a:xfrm>
+            <a:prstGeom prst="roundRect">
+              <a:avLst>
+                <a:gd name="adj" fmla="val 21875"/>
+              </a:avLst>
+            </a:prstGeom>
+            <a:solidFill>
+              <a:srgbClr val="EFF6FF"/>
+            </a:solidFill>
+            <a:ln w="12700">
+              <a:solidFill>
+                <a:srgbClr val="BFDBFE"/>
+              </a:solidFill>
+              <a:prstDash val="solid"/>
+            </a:ln>
+          </p:spPr>
+        </p:sp>
+        <p:sp>
+          <p:nvSpPr>
+            <p:cNvPr id="21" name="Text 19"/>
+            <p:cNvSpPr/>
+            <p:nvPr/>
+          </p:nvSpPr>
+          <p:spPr>
+            <a:xfrm>
+              <a:off x="676656" y="4791456"/>
+              <a:ext cx="2852928" cy="292608"/>
+            </a:xfrm>
+            <a:prstGeom prst="rect">
+              <a:avLst/>
+            </a:prstGeom>
+            <a:noFill/>
+            <a:ln/>
+          </p:spPr>
+          <p:txBody>
+            <a:bodyPr wrap="square" lIns="0" tIns="0" rIns="0" bIns="0" rtlCol="0" anchor="ctr"/>
+            <a:lstStyle/>
+            <a:p>
+              <a:pPr marL="0" indent="0">
+                <a:buNone/>
+              </a:pPr>
+              <a:r>
+                <a:rPr lang="en-US" sz="1100" b="1" dirty="0">
+                  <a:solidFill>
+                    <a:srgbClr val="1456F0"/>
+                  </a:solidFill>
+                  <a:latin typeface="Pretendard" pitchFamily="34" charset="0"/>
+                  <a:ea typeface="Pretendard" pitchFamily="34" charset="-122"/>
+                  <a:cs typeface="Pretendard" pitchFamily="34" charset="-120"/>
+                </a:rPr>
+                <a:t>evaluate.py</a:t>
+              </a:r>
+              <a:endParaRPr lang="en-US" sz="1100" dirty="0"/>
+            </a:p>
+          </p:txBody>
+        </p:sp>
+        <p:sp>
+          <p:nvSpPr>
+            <p:cNvPr id="22" name="Text 20"/>
+            <p:cNvSpPr/>
+            <p:nvPr/>
+          </p:nvSpPr>
+          <p:spPr>
+            <a:xfrm>
+              <a:off x="3730752" y="4636008"/>
+              <a:ext cx="7820863" cy="548640"/>
+            </a:xfrm>
+            <a:prstGeom prst="rect">
+              <a:avLst/>
+            </a:prstGeom>
+            <a:noFill/>
+            <a:ln/>
+          </p:spPr>
+          <p:txBody>
+            <a:bodyPr wrap="square" lIns="0" tIns="0" rIns="0" bIns="0" rtlCol="0" anchor="ctr"/>
+            <a:lstStyle/>
+            <a:p>
+              <a:pPr marL="0" indent="0">
+                <a:buNone/>
+              </a:pPr>
+              <a:r>
+                <a:rPr lang="en-US" sz="1200" dirty="0">
+                  <a:solidFill>
+                    <a:srgbClr val="45515E"/>
+                  </a:solidFill>
+                  <a:latin typeface="Pretendard" pitchFamily="34" charset="0"/>
+                  <a:ea typeface="Pretendard" pitchFamily="34" charset="-122"/>
+                  <a:cs typeface="Pretendard" pitchFamily="34" charset="-120"/>
+                </a:rPr>
+                <a:t>— CV, holdout, GridSearch, ablations</a:t>
+              </a:r>
+              <a:endParaRPr lang="en-US" sz="1200" dirty="0"/>
+            </a:p>
+          </p:txBody>
+        </p:sp>
+        <p:sp>
+          <p:nvSpPr>
+            <p:cNvPr id="23" name="Shape 21"/>
+            <p:cNvSpPr/>
+            <p:nvPr/>
+          </p:nvSpPr>
+          <p:spPr>
+            <a:xfrm>
+              <a:off x="457200" y="5285232"/>
+              <a:ext cx="11277295" cy="548640"/>
+            </a:xfrm>
+            <a:prstGeom prst="roundRect">
+              <a:avLst>
+                <a:gd name="adj" fmla="val 15000"/>
+              </a:avLst>
+            </a:prstGeom>
+            <a:solidFill>
+              <a:srgbClr val="FFFFFF"/>
+            </a:solidFill>
+            <a:ln w="12700">
+              <a:solidFill>
+                <a:srgbClr val="E5E7EB"/>
+              </a:solidFill>
+              <a:prstDash val="solid"/>
+            </a:ln>
+            <a:effectLst>
+              <a:outerShdw blurRad="101600" dist="50800" dir="8100000" algn="bl" rotWithShape="0">
+                <a:srgbClr val="000000">
+                  <a:alpha val="8000"/>
+                </a:srgbClr>
+              </a:outerShdw>
+            </a:effectLst>
+          </p:spPr>
+        </p:sp>
+        <p:sp>
+          <p:nvSpPr>
+            <p:cNvPr id="24" name="Shape 22"/>
+            <p:cNvSpPr/>
+            <p:nvPr/>
+          </p:nvSpPr>
+          <p:spPr>
+            <a:xfrm>
+              <a:off x="457200" y="5285232"/>
+              <a:ext cx="54864" cy="548640"/>
+            </a:xfrm>
+            <a:prstGeom prst="rect">
+              <a:avLst/>
+            </a:prstGeom>
+            <a:solidFill>
+              <a:srgbClr val="3B82F6"/>
+            </a:solidFill>
+            <a:ln/>
+          </p:spPr>
+        </p:sp>
+        <p:sp>
+          <p:nvSpPr>
+            <p:cNvPr id="25" name="Shape 23"/>
+            <p:cNvSpPr/>
+            <p:nvPr/>
+          </p:nvSpPr>
+          <p:spPr>
+            <a:xfrm>
+              <a:off x="640080" y="5440680"/>
+              <a:ext cx="2926080" cy="292608"/>
+            </a:xfrm>
+            <a:prstGeom prst="roundRect">
+              <a:avLst>
+                <a:gd name="adj" fmla="val 21875"/>
+              </a:avLst>
+            </a:prstGeom>
+            <a:solidFill>
+              <a:srgbClr val="EFF6FF"/>
+            </a:solidFill>
+            <a:ln w="12700">
+              <a:solidFill>
+                <a:srgbClr val="BFDBFE"/>
+              </a:solidFill>
+              <a:prstDash val="solid"/>
+            </a:ln>
+          </p:spPr>
+        </p:sp>
+        <p:sp>
+          <p:nvSpPr>
+            <p:cNvPr id="26" name="Text 24"/>
+            <p:cNvSpPr/>
+            <p:nvPr/>
+          </p:nvSpPr>
+          <p:spPr>
+            <a:xfrm>
+              <a:off x="676656" y="5440680"/>
+              <a:ext cx="2852928" cy="292608"/>
+            </a:xfrm>
+            <a:prstGeom prst="rect">
+              <a:avLst/>
+            </a:prstGeom>
+            <a:noFill/>
+            <a:ln/>
+          </p:spPr>
+          <p:txBody>
+            <a:bodyPr wrap="square" lIns="0" tIns="0" rIns="0" bIns="0" rtlCol="0" anchor="ctr"/>
+            <a:lstStyle/>
+            <a:p>
+              <a:pPr marL="0" indent="0">
+                <a:buNone/>
+              </a:pPr>
+              <a:r>
+                <a:rPr lang="en-US" sz="1100" b="1" dirty="0">
+                  <a:solidFill>
+                    <a:srgbClr val="1456F0"/>
+                  </a:solidFill>
+                  <a:latin typeface="Pretendard" pitchFamily="34" charset="0"/>
+                  <a:ea typeface="Pretendard" pitchFamily="34" charset="-122"/>
+                  <a:cs typeface="Pretendard" pitchFamily="34" charset="-120"/>
+                </a:rPr>
+                <a:t>auxiliary.py</a:t>
+              </a:r>
+              <a:endParaRPr lang="en-US" sz="1100" dirty="0"/>
+            </a:p>
+          </p:txBody>
+        </p:sp>
+        <p:sp>
+          <p:nvSpPr>
+            <p:cNvPr id="27" name="Text 25"/>
+            <p:cNvSpPr/>
+            <p:nvPr/>
+          </p:nvSpPr>
+          <p:spPr>
+            <a:xfrm>
+              <a:off x="3730752" y="5285232"/>
+              <a:ext cx="7820863" cy="548640"/>
+            </a:xfrm>
+            <a:prstGeom prst="rect">
+              <a:avLst/>
+            </a:prstGeom>
+            <a:noFill/>
+            <a:ln/>
+          </p:spPr>
+          <p:txBody>
+            <a:bodyPr wrap="square" lIns="0" tIns="0" rIns="0" bIns="0" rtlCol="0" anchor="ctr"/>
+            <a:lstStyle/>
+            <a:p>
+              <a:pPr marL="0" indent="0">
+                <a:buNone/>
+              </a:pPr>
+              <a:r>
+                <a:rPr lang="en-US" sz="1200" dirty="0">
+                  <a:solidFill>
+                    <a:srgbClr val="45515E"/>
+                  </a:solidFill>
+                  <a:latin typeface="Pretendard" pitchFamily="34" charset="0"/>
+                  <a:ea typeface="Pretendard" pitchFamily="34" charset="-122"/>
+                  <a:cs typeface="Pretendard" pitchFamily="34" charset="-120"/>
+                </a:rPr>
+                <a:t>— regression, clustering</a:t>
+              </a:r>
+              <a:endParaRPr lang="en-US" sz="1200" dirty="0"/>
+            </a:p>
+          </p:txBody>
+        </p:sp>
+        <p:sp>
+          <p:nvSpPr>
+            <p:cNvPr id="28" name="Shape 26"/>
+            <p:cNvSpPr/>
+            <p:nvPr/>
+          </p:nvSpPr>
+          <p:spPr>
+            <a:xfrm>
+              <a:off x="457200" y="5934456"/>
+              <a:ext cx="11277295" cy="548640"/>
+            </a:xfrm>
+            <a:prstGeom prst="roundRect">
+              <a:avLst>
+                <a:gd name="adj" fmla="val 15000"/>
+              </a:avLst>
+            </a:prstGeom>
+            <a:solidFill>
+              <a:srgbClr val="FFFFFF"/>
+            </a:solidFill>
+            <a:ln w="12700">
+              <a:solidFill>
+                <a:srgbClr val="E5E7EB"/>
+              </a:solidFill>
+              <a:prstDash val="solid"/>
+            </a:ln>
+            <a:effectLst>
+              <a:outerShdw blurRad="101600" dist="50800" dir="8100000" algn="bl" rotWithShape="0">
+                <a:srgbClr val="000000">
+                  <a:alpha val="8000"/>
+                </a:srgbClr>
+              </a:outerShdw>
+            </a:effectLst>
+          </p:spPr>
+        </p:sp>
+        <p:sp>
+          <p:nvSpPr>
+            <p:cNvPr id="29" name="Shape 27"/>
+            <p:cNvSpPr/>
+            <p:nvPr/>
+          </p:nvSpPr>
+          <p:spPr>
+            <a:xfrm>
+              <a:off x="457200" y="5934456"/>
+              <a:ext cx="54864" cy="548640"/>
+            </a:xfrm>
+            <a:prstGeom prst="rect">
+              <a:avLst/>
+            </a:prstGeom>
+            <a:solidFill>
+              <a:srgbClr val="3B82F6"/>
+            </a:solidFill>
+            <a:ln/>
+          </p:spPr>
+        </p:sp>
+        <p:sp>
+          <p:nvSpPr>
+            <p:cNvPr id="30" name="Shape 28"/>
+            <p:cNvSpPr/>
+            <p:nvPr/>
+          </p:nvSpPr>
+          <p:spPr>
+            <a:xfrm>
+              <a:off x="640080" y="6089904"/>
+              <a:ext cx="2926080" cy="292608"/>
+            </a:xfrm>
+            <a:prstGeom prst="roundRect">
+              <a:avLst>
+                <a:gd name="adj" fmla="val 21875"/>
+              </a:avLst>
+            </a:prstGeom>
+            <a:solidFill>
+              <a:srgbClr val="EFF6FF"/>
+            </a:solidFill>
+            <a:ln w="12700">
+              <a:solidFill>
+                <a:srgbClr val="BFDBFE"/>
+              </a:solidFill>
+              <a:prstDash val="solid"/>
+            </a:ln>
+          </p:spPr>
+        </p:sp>
+        <p:sp>
+          <p:nvSpPr>
+            <p:cNvPr id="31" name="Text 29"/>
+            <p:cNvSpPr/>
+            <p:nvPr/>
+          </p:nvSpPr>
+          <p:spPr>
+            <a:xfrm>
+              <a:off x="676656" y="6089904"/>
+              <a:ext cx="2852928" cy="292608"/>
+            </a:xfrm>
+            <a:prstGeom prst="rect">
+              <a:avLst/>
+            </a:prstGeom>
+            <a:noFill/>
+            <a:ln/>
+          </p:spPr>
+          <p:txBody>
+            <a:bodyPr wrap="square" lIns="0" tIns="0" rIns="0" bIns="0" rtlCol="0" anchor="ctr"/>
+            <a:lstStyle/>
+            <a:p>
+              <a:pPr marL="0" indent="0">
+                <a:buNone/>
+              </a:pPr>
+              <a:r>
+                <a:rPr lang="en-US" sz="1100" b="1" dirty="0">
+                  <a:solidFill>
+                    <a:srgbClr val="1456F0"/>
+                  </a:solidFill>
+                  <a:latin typeface="Pretendard" pitchFamily="34" charset="0"/>
+                  <a:ea typeface="Pretendard" pitchFamily="34" charset="-122"/>
+                  <a:cs typeface="Pretendard" pitchFamily="34" charset="-120"/>
+                </a:rPr>
+                <a:t>visualize.py / eda.py / train.py</a:t>
+              </a:r>
+              <a:endParaRPr lang="en-US" sz="1100" dirty="0"/>
+            </a:p>
+          </p:txBody>
+        </p:sp>
+        <p:sp>
+          <p:nvSpPr>
+            <p:cNvPr id="32" name="Text 30"/>
+            <p:cNvSpPr/>
+            <p:nvPr/>
+          </p:nvSpPr>
+          <p:spPr>
+            <a:xfrm>
+              <a:off x="3730752" y="5934456"/>
+              <a:ext cx="7820863" cy="548640"/>
+            </a:xfrm>
+            <a:prstGeom prst="rect">
+              <a:avLst/>
+            </a:prstGeom>
+            <a:noFill/>
+            <a:ln/>
+          </p:spPr>
+          <p:txBody>
+            <a:bodyPr wrap="square" lIns="0" tIns="0" rIns="0" bIns="0" rtlCol="0" anchor="ctr"/>
+            <a:lstStyle/>
+            <a:p>
+              <a:pPr marL="0" indent="0">
+                <a:buNone/>
+              </a:pPr>
+              <a:r>
+                <a:rPr lang="en-US" sz="1200" dirty="0">
+                  <a:solidFill>
+                    <a:srgbClr val="45515E"/>
+                  </a:solidFill>
+                  <a:latin typeface="Pretendard" pitchFamily="34" charset="0"/>
+                  <a:ea typeface="Pretendard" pitchFamily="34" charset="-122"/>
+                  <a:cs typeface="Pretendard" pitchFamily="34" charset="-120"/>
+                </a:rPr>
+                <a:t>— 시각화, EDA, 전체 파이프라인 CLI</a:t>
+              </a:r>
+              <a:endParaRPr lang="en-US" sz="1200" dirty="0"/>
+            </a:p>
+          </p:txBody>
+        </p:sp>
+        <p:sp>
+          <p:nvSpPr>
+            <p:cNvPr id="33" name="Text 31"/>
+            <p:cNvSpPr/>
+            <p:nvPr/>
+          </p:nvSpPr>
+          <p:spPr>
+            <a:xfrm>
+              <a:off x="457200" y="6446520"/>
+              <a:ext cx="914400" cy="228600"/>
+            </a:xfrm>
+            <a:prstGeom prst="rect">
+              <a:avLst/>
+            </a:prstGeom>
+            <a:noFill/>
+            <a:ln/>
+          </p:spPr>
+          <p:txBody>
+            <a:bodyPr wrap="square" lIns="0" tIns="0" rIns="0" bIns="0" rtlCol="0" anchor="ctr"/>
+            <a:lstStyle/>
+            <a:p>
+              <a:pPr marL="0" indent="0">
+                <a:buNone/>
+              </a:pPr>
+              <a:r>
+                <a:rPr lang="en-US" sz="1000" dirty="0">
+                  <a:solidFill>
+                    <a:srgbClr val="8E8E93"/>
+                  </a:solidFill>
+                  <a:latin typeface="Pretendard" pitchFamily="34" charset="0"/>
+                  <a:ea typeface="Pretendard" pitchFamily="34" charset="-122"/>
+                  <a:cs typeface="Pretendard" pitchFamily="34" charset="-120"/>
+                </a:rPr>
+                <a:t>9</a:t>
+              </a:r>
+              <a:endParaRPr lang="en-US" sz="1000" dirty="0"/>
+            </a:p>
+          </p:txBody>
+        </p:sp>
+      </p:grpSp>
+      <p:sp>
+        <p:nvSpPr>
+          <p:cNvPr id="34" name="Text 32"/>
+          <p:cNvSpPr/>
+          <p:nvPr/>
+        </p:nvSpPr>
+        <p:spPr>
+          <a:xfrm>
+            <a:off x="-213064" y="6446520"/>
+            <a:ext cx="12191695" cy="228600"/>
+          </a:xfrm>
+          <a:prstGeom prst="rect">
+            <a:avLst/>
+          </a:prstGeom>
+          <a:noFill/>
+          <a:ln/>
+        </p:spPr>
+        <p:txBody>
+          <a:bodyPr wrap="square" lIns="0" tIns="0" rIns="6350" bIns="0" rtlCol="0" anchor="ctr"/>
+          <a:lstStyle/>
+          <a:p>
+            <a:pPr marL="0" indent="0" algn="r">
+              <a:buNone/>
+            </a:pPr>
+            <a:r>
+              <a:rPr lang="en-US" sz="900" dirty="0">
+                <a:solidFill>
+                  <a:srgbClr val="8E8E93"/>
+                </a:solidFill>
+                <a:latin typeface="Pretendard" pitchFamily="34" charset="0"/>
+                <a:ea typeface="Pretendard" pitchFamily="34" charset="-122"/>
+                <a:cs typeface="Pretendard" pitchFamily="34" charset="-120"/>
+              </a:rPr>
+              <a:t>Team 6 Data Science Term Project</a:t>
+            </a:r>
+            <a:endParaRPr lang="en-US" sz="900" dirty="0"/>
+          </a:p>
+        </p:txBody>
+      </p:sp>
+      <p:sp>
+        <p:nvSpPr>
+          <p:cNvPr id="37" name="TopBar">
+            <a:extLst>
+              <a:ext uri="{FF2B5EF4-FFF2-40B4-BE49-F238E27FC236}">
+                <a16:creationId xmlns:a16="http://schemas.microsoft.com/office/drawing/2014/main" id="{F22BE863-EBAD-43A4-9D62-96B5FC47E741}"/>
+              </a:ext>
+            </a:extLst>
+          </p:cNvPr>
+          <p:cNvSpPr/>
+          <p:nvPr/>
+        </p:nvSpPr>
+        <p:spPr>
+          <a:xfrm>
+            <a:off x="0" y="-26633"/>
+            <a:ext cx="12191695" cy="128016"/>
+          </a:xfrm>
+          <a:prstGeom prst="rect">
+            <a:avLst/>
+          </a:prstGeom>
+          <a:solidFill>
+            <a:srgbClr val="0F766E"/>
+          </a:solidFill>
+          <a:ln w="12700">
+            <a:solidFill>
+              <a:srgbClr val="0F766E"/>
+            </a:solidFill>
+            <a:prstDash val="solid"/>
+          </a:ln>
+        </p:spPr>
+        <p:txBody>
+          <a:bodyPr/>
+          <a:lstStyle/>
+          <a:p>
+            <a:endParaRPr lang="ko-KR" altLang="en-US"/>
           </a:p>
         </p:txBody>
       </p:sp>

</xml_diff>